<commit_message>
release 1.0.0.dev1: radiometric analysis, new format support (novasar-1, iceye)
</commit_message>
<xml_diff>
--- a/documentation/new_sct_status_update.pptx
+++ b/documentation/new_sct_status_update.pptx
@@ -5,24 +5,23 @@
     <p:sldMasterId id="2147483696" r:id="rId4"/>
   </p:sldMasterIdLst>
   <p:notesMasterIdLst>
-    <p:notesMasterId r:id="rId20"/>
+    <p:notesMasterId r:id="rId19"/>
   </p:notesMasterIdLst>
   <p:sldIdLst>
     <p:sldId id="306" r:id="rId5"/>
     <p:sldId id="304" r:id="rId6"/>
     <p:sldId id="317" r:id="rId7"/>
-    <p:sldId id="324" r:id="rId8"/>
-    <p:sldId id="327" r:id="rId9"/>
-    <p:sldId id="313" r:id="rId10"/>
-    <p:sldId id="321" r:id="rId11"/>
-    <p:sldId id="328" r:id="rId12"/>
-    <p:sldId id="322" r:id="rId13"/>
-    <p:sldId id="323" r:id="rId14"/>
-    <p:sldId id="319" r:id="rId15"/>
-    <p:sldId id="325" r:id="rId16"/>
-    <p:sldId id="326" r:id="rId17"/>
-    <p:sldId id="316" r:id="rId18"/>
-    <p:sldId id="312" r:id="rId19"/>
+    <p:sldId id="329" r:id="rId8"/>
+    <p:sldId id="324" r:id="rId9"/>
+    <p:sldId id="327" r:id="rId10"/>
+    <p:sldId id="313" r:id="rId11"/>
+    <p:sldId id="321" r:id="rId12"/>
+    <p:sldId id="328" r:id="rId13"/>
+    <p:sldId id="319" r:id="rId14"/>
+    <p:sldId id="325" r:id="rId15"/>
+    <p:sldId id="326" r:id="rId16"/>
+    <p:sldId id="316" r:id="rId17"/>
+    <p:sldId id="312" r:id="rId18"/>
   </p:sldIdLst>
   <p:sldSz cx="12192000" cy="6858000"/>
   <p:notesSz cx="6858000" cy="9144000"/>
@@ -133,6 +132,7 @@
           <p14:sldIdLst>
             <p14:sldId id="304"/>
             <p14:sldId id="317"/>
+            <p14:sldId id="329"/>
             <p14:sldId id="324"/>
             <p14:sldId id="327"/>
           </p14:sldIdLst>
@@ -146,8 +146,6 @@
         </p14:section>
         <p14:section name="Information Needed" id="{FF477CC1-6478-4628-AAF0-A09AAB0E0F10}">
           <p14:sldIdLst>
-            <p14:sldId id="322"/>
-            <p14:sldId id="323"/>
             <p14:sldId id="319"/>
             <p14:sldId id="325"/>
             <p14:sldId id="326"/>
@@ -272,7 +270,7 @@
           <a:p>
             <a:fld id="{5EA28068-AFBD-4979-B752-9EB6F90B1386}" type="datetimeFigureOut">
               <a:rPr lang="en-US" smtClean="0"/>
-              <a:t>12/4/2023</a:t>
+              <a:t>2/12/2024</a:t>
             </a:fld>
             <a:endParaRPr lang="en-US" dirty="0"/>
           </a:p>
@@ -11304,7 +11302,7 @@
                   <a:schemeClr val="bg1"/>
                 </a:solidFill>
               </a:rPr>
-              <a:t>v1.3</a:t>
+              <a:t>v1.5</a:t>
             </a:r>
             <a:endParaRPr lang="en-US" dirty="0"/>
           </a:p>
@@ -11456,7 +11454,7 @@
             </a:r>
             <a:r>
               <a:rPr lang="en-US" sz="3600" dirty="0"/>
-              <a:t>– Operation Modes</a:t>
+              <a:t>– Calibration Sites</a:t>
             </a:r>
           </a:p>
         </p:txBody>
@@ -11475,8 +11473,8 @@
         </p:nvSpPr>
         <p:spPr>
           <a:xfrm>
-            <a:off x="942391" y="2155372"/>
-            <a:ext cx="10795519" cy="2200602"/>
+            <a:off x="942391" y="2006082"/>
+            <a:ext cx="10795519" cy="3647152"/>
           </a:xfrm>
           <a:prstGeom prst="rect">
             <a:avLst/>
@@ -11491,36 +11489,74 @@
           <a:p>
             <a:r>
               <a:rPr lang="en-US" sz="2800" dirty="0"/>
-              <a:t>Define SCT CLI operation modes:</a:t>
+              <a:t>Calibration sites DB management:</a:t>
             </a:r>
           </a:p>
           <a:p>
             <a:endParaRPr lang="en-US" sz="2800" dirty="0"/>
           </a:p>
           <a:p>
-            <a:pPr marL="457200" indent="-457200">
+            <a:pPr marL="285750" indent="-285750">
+              <a:spcBef>
+                <a:spcPts val="600"/>
+              </a:spcBef>
               <a:spcAft>
-                <a:spcPts val="3000"/>
+                <a:spcPts val="600"/>
               </a:spcAft>
               <a:buFont typeface="Arial" panose="020B0604020202020204" pitchFamily="34" charset="0"/>
               <a:buChar char="•"/>
             </a:pPr>
             <a:r>
               <a:rPr lang="en-US" sz="2800" dirty="0"/>
-              <a:t>Commands</a:t>
-            </a:r>
-          </a:p>
-          <a:p>
-            <a:pPr marL="457200" indent="-457200">
+              <a:t>How to manage calibration sites different from Surat Basin?</a:t>
+            </a:r>
+          </a:p>
+          <a:p>
+            <a:pPr marL="285750" indent="-285750">
+              <a:spcBef>
+                <a:spcPts val="600"/>
+              </a:spcBef>
               <a:spcAft>
-                <a:spcPts val="3000"/>
+                <a:spcPts val="600"/>
               </a:spcAft>
               <a:buFont typeface="Arial" panose="020B0604020202020204" pitchFamily="34" charset="0"/>
               <a:buChar char="•"/>
             </a:pPr>
             <a:r>
               <a:rPr lang="en-US" sz="2800" dirty="0"/>
-              <a:t>Analysis flow: input parameters, workflow, output</a:t>
+              <a:t>Delays? RCS? In DB or to be evaluated through formulas? (if they are signal dependent, they cannot be in a DB)</a:t>
+            </a:r>
+          </a:p>
+          <a:p>
+            <a:pPr marL="285750" indent="-285750">
+              <a:spcBef>
+                <a:spcPts val="600"/>
+              </a:spcBef>
+              <a:spcAft>
+                <a:spcPts val="600"/>
+              </a:spcAft>
+              <a:buFont typeface="Arial" panose="020B0604020202020204" pitchFamily="34" charset="0"/>
+              <a:buChar char="•"/>
+            </a:pPr>
+            <a:r>
+              <a:rPr lang="en-US" sz="2800" dirty="0"/>
+              <a:t>Support for external .csv template source file</a:t>
+            </a:r>
+          </a:p>
+          <a:p>
+            <a:pPr marL="285750" indent="-285750">
+              <a:spcBef>
+                <a:spcPts val="600"/>
+              </a:spcBef>
+              <a:spcAft>
+                <a:spcPts val="600"/>
+              </a:spcAft>
+              <a:buFont typeface="Arial" panose="020B0604020202020204" pitchFamily="34" charset="0"/>
+              <a:buChar char="•"/>
+            </a:pPr>
+            <a:r>
+              <a:rPr lang="en-US" sz="2800" dirty="0"/>
+              <a:t>Rosamond? Very difficult to add to DB</a:t>
             </a:r>
           </a:p>
         </p:txBody>
@@ -11574,7 +11610,7 @@
     </p:spTree>
     <p:extLst>
       <p:ext uri="{BB962C8B-B14F-4D97-AF65-F5344CB8AC3E}">
-        <p14:creationId xmlns:p14="http://schemas.microsoft.com/office/powerpoint/2010/main" val="3771310397"/>
+        <p14:creationId xmlns:p14="http://schemas.microsoft.com/office/powerpoint/2010/main" val="1464788498"/>
       </p:ext>
     </p:extLst>
   </p:cSld>
@@ -11635,7 +11671,7 @@
             </a:r>
             <a:r>
               <a:rPr lang="en-US" sz="3600" dirty="0"/>
-              <a:t>– Calibration Sites</a:t>
+              <a:t>– Web Scraping</a:t>
             </a:r>
           </a:p>
         </p:txBody>
@@ -11654,8 +11690,8 @@
         </p:nvSpPr>
         <p:spPr>
           <a:xfrm>
-            <a:off x="942391" y="2006082"/>
-            <a:ext cx="10795519" cy="3647152"/>
+            <a:off x="942391" y="2225157"/>
+            <a:ext cx="10795519" cy="3539430"/>
           </a:xfrm>
           <a:prstGeom prst="rect">
             <a:avLst/>
@@ -11670,74 +11706,55 @@
           <a:p>
             <a:r>
               <a:rPr lang="en-US" sz="2800" dirty="0"/>
-              <a:t>Calibration sites DB management:</a:t>
+              <a:t>Automatic download of what is needed to perform a complete</a:t>
+            </a:r>
+          </a:p>
+          <a:p>
+            <a:r>
+              <a:rPr lang="en-US" sz="2800" dirty="0"/>
+              <a:t>Analysis:</a:t>
             </a:r>
           </a:p>
           <a:p>
             <a:endParaRPr lang="en-US" sz="2800" dirty="0"/>
           </a:p>
           <a:p>
-            <a:pPr marL="285750" indent="-285750">
-              <a:spcBef>
-                <a:spcPts val="600"/>
-              </a:spcBef>
-              <a:spcAft>
-                <a:spcPts val="600"/>
-              </a:spcAft>
+            <a:pPr marL="457200" indent="-457200">
               <a:buFont typeface="Arial" panose="020B0604020202020204" pitchFamily="34" charset="0"/>
               <a:buChar char="•"/>
             </a:pPr>
             <a:r>
               <a:rPr lang="en-US" sz="2800" dirty="0"/>
-              <a:t>How to manage calibration sites different from Surat Basin?</a:t>
-            </a:r>
-          </a:p>
-          <a:p>
-            <a:pPr marL="285750" indent="-285750">
-              <a:spcBef>
-                <a:spcPts val="600"/>
-              </a:spcBef>
-              <a:spcAft>
-                <a:spcPts val="600"/>
-              </a:spcAft>
+              <a:t>Rosamond point target data download (free access) DONE</a:t>
+            </a:r>
+          </a:p>
+          <a:p>
+            <a:pPr marL="457200" indent="-457200">
               <a:buFont typeface="Arial" panose="020B0604020202020204" pitchFamily="34" charset="0"/>
               <a:buChar char="•"/>
             </a:pPr>
             <a:r>
               <a:rPr lang="en-US" sz="2800" dirty="0"/>
-              <a:t>Delays? RCS? In DB or to be evaluated through formulas? (if they are signal dependent, they cannot be in a DB)</a:t>
-            </a:r>
-          </a:p>
-          <a:p>
-            <a:pPr marL="285750" indent="-285750">
-              <a:spcBef>
-                <a:spcPts val="600"/>
-              </a:spcBef>
-              <a:spcAft>
-                <a:spcPts val="600"/>
-              </a:spcAft>
+              <a:t>Troposphere maps download (free access) DONE</a:t>
+            </a:r>
+          </a:p>
+          <a:p>
+            <a:pPr marL="457200" indent="-457200">
               <a:buFont typeface="Arial" panose="020B0604020202020204" pitchFamily="34" charset="0"/>
               <a:buChar char="•"/>
             </a:pPr>
             <a:r>
               <a:rPr lang="en-US" sz="2800" dirty="0"/>
-              <a:t>Support for external .csv template source file</a:t>
-            </a:r>
-          </a:p>
-          <a:p>
-            <a:pPr marL="285750" indent="-285750">
-              <a:spcBef>
-                <a:spcPts val="600"/>
-              </a:spcBef>
-              <a:spcAft>
-                <a:spcPts val="600"/>
-              </a:spcAft>
-              <a:buFont typeface="Arial" panose="020B0604020202020204" pitchFamily="34" charset="0"/>
-              <a:buChar char="•"/>
-            </a:pPr>
+              <a:t>Ionosphere maps download (authentication needed)</a:t>
+            </a:r>
+          </a:p>
+          <a:p>
+            <a:endParaRPr lang="en-US" sz="2800" dirty="0"/>
+          </a:p>
+          <a:p>
             <a:r>
               <a:rPr lang="en-US" sz="2800" dirty="0"/>
-              <a:t>Rosamond? Very difficult to add to DB</a:t>
+              <a:t>As a separate module? Internal only?</a:t>
             </a:r>
           </a:p>
         </p:txBody>
@@ -11791,7 +11808,7 @@
     </p:spTree>
     <p:extLst>
       <p:ext uri="{BB962C8B-B14F-4D97-AF65-F5344CB8AC3E}">
-        <p14:creationId xmlns:p14="http://schemas.microsoft.com/office/powerpoint/2010/main" val="1464788498"/>
+        <p14:creationId xmlns:p14="http://schemas.microsoft.com/office/powerpoint/2010/main" val="3011220951"/>
       </p:ext>
     </p:extLst>
   </p:cSld>
@@ -11852,7 +11869,7 @@
             </a:r>
             <a:r>
               <a:rPr lang="en-US" sz="3600" dirty="0"/>
-              <a:t>– Web Scraping</a:t>
+              <a:t>– Open-Source Boundaries</a:t>
             </a:r>
           </a:p>
         </p:txBody>
@@ -11872,7 +11889,7 @@
         <p:spPr>
           <a:xfrm>
             <a:off x="942391" y="2225157"/>
-            <a:ext cx="10795519" cy="3539430"/>
+            <a:ext cx="10795519" cy="1815882"/>
           </a:xfrm>
           <a:prstGeom prst="rect">
             <a:avLst/>
@@ -11887,56 +11904,20 @@
           <a:p>
             <a:r>
               <a:rPr lang="en-US" sz="2800" dirty="0"/>
-              <a:t>Automatic download of what is needed to perform a complete</a:t>
-            </a:r>
+              <a:t>Understand what’s open-source and what’s not.</a:t>
+            </a:r>
+          </a:p>
+          <a:p>
+            <a:endParaRPr lang="en-US" sz="2800" dirty="0"/>
           </a:p>
           <a:p>
             <a:r>
               <a:rPr lang="en-US" sz="2800" dirty="0"/>
-              <a:t>Analysis:</a:t>
+              <a:t>Define boundaries for the application as per ESA request.</a:t>
             </a:r>
           </a:p>
           <a:p>
             <a:endParaRPr lang="en-US" sz="2800" dirty="0"/>
-          </a:p>
-          <a:p>
-            <a:pPr marL="457200" indent="-457200">
-              <a:buFont typeface="Arial" panose="020B0604020202020204" pitchFamily="34" charset="0"/>
-              <a:buChar char="•"/>
-            </a:pPr>
-            <a:r>
-              <a:rPr lang="en-US" sz="2800" dirty="0"/>
-              <a:t>Rosamond point target data download (free access)</a:t>
-            </a:r>
-          </a:p>
-          <a:p>
-            <a:pPr marL="457200" indent="-457200">
-              <a:buFont typeface="Arial" panose="020B0604020202020204" pitchFamily="34" charset="0"/>
-              <a:buChar char="•"/>
-            </a:pPr>
-            <a:r>
-              <a:rPr lang="en-US" sz="2800" dirty="0"/>
-              <a:t>Troposphere maps download (free access)</a:t>
-            </a:r>
-          </a:p>
-          <a:p>
-            <a:pPr marL="457200" indent="-457200">
-              <a:buFont typeface="Arial" panose="020B0604020202020204" pitchFamily="34" charset="0"/>
-              <a:buChar char="•"/>
-            </a:pPr>
-            <a:r>
-              <a:rPr lang="en-US" sz="2800" dirty="0"/>
-              <a:t>Ionosphere maps download (authentication needed)</a:t>
-            </a:r>
-          </a:p>
-          <a:p>
-            <a:endParaRPr lang="en-US" sz="2800" dirty="0"/>
-          </a:p>
-          <a:p>
-            <a:r>
-              <a:rPr lang="en-US" sz="2800" dirty="0"/>
-              <a:t>As a separate module? Internal only?</a:t>
-            </a:r>
           </a:p>
         </p:txBody>
       </p:sp>
@@ -11989,7 +11970,7 @@
     </p:spTree>
     <p:extLst>
       <p:ext uri="{BB962C8B-B14F-4D97-AF65-F5344CB8AC3E}">
-        <p14:creationId xmlns:p14="http://schemas.microsoft.com/office/powerpoint/2010/main" val="3011220951"/>
+        <p14:creationId xmlns:p14="http://schemas.microsoft.com/office/powerpoint/2010/main" val="3641827516"/>
       </p:ext>
     </p:extLst>
   </p:cSld>
@@ -12046,11 +12027,11 @@
           <a:p>
             <a:r>
               <a:rPr lang="en-US" sz="3600" cap="small" dirty="0"/>
-              <a:t>Private side </a:t>
+              <a:t>Public Side </a:t>
             </a:r>
             <a:r>
               <a:rPr lang="en-US" sz="3600" dirty="0"/>
-              <a:t>– Open-Source Boundaries</a:t>
+              <a:t>– Status Updates</a:t>
             </a:r>
           </a:p>
         </p:txBody>
@@ -12069,8 +12050,8 @@
         </p:nvSpPr>
         <p:spPr>
           <a:xfrm>
-            <a:off x="942391" y="2225157"/>
-            <a:ext cx="10795519" cy="1815882"/>
+            <a:off x="979712" y="2672179"/>
+            <a:ext cx="10795519" cy="1754326"/>
           </a:xfrm>
           <a:prstGeom prst="rect">
             <a:avLst/>
@@ -12084,30 +12065,121 @@
           <a:lstStyle/>
           <a:p>
             <a:r>
-              <a:rPr lang="en-US" sz="2800" dirty="0"/>
-              <a:t>Understand what’s open-source and what’s not.</a:t>
-            </a:r>
-          </a:p>
-          <a:p>
-            <a:endParaRPr lang="en-US" sz="2800" dirty="0"/>
-          </a:p>
-          <a:p>
-            <a:r>
-              <a:rPr lang="en-US" sz="2800" dirty="0"/>
-              <a:t>Define boundaries for the application as per ESA request.</a:t>
-            </a:r>
-          </a:p>
-          <a:p>
-            <a:endParaRPr lang="en-US" sz="2800" dirty="0"/>
-          </a:p>
-        </p:txBody>
-      </p:sp>
-      <p:sp>
-        <p:nvSpPr>
-          <p:cNvPr id="4" name="TextBox 3">
-            <a:extLst>
-              <a:ext uri="{FF2B5EF4-FFF2-40B4-BE49-F238E27FC236}">
-                <a16:creationId xmlns:a16="http://schemas.microsoft.com/office/drawing/2014/main" id="{71D1F55A-C667-B0F5-1D6D-EC547AD40213}"/>
+              <a:rPr lang="en-US" b="1" cap="small" dirty="0" err="1"/>
+              <a:t>Arepyextras</a:t>
+            </a:r>
+            <a:endParaRPr lang="en-US" b="1" cap="small" dirty="0"/>
+          </a:p>
+          <a:p>
+            <a:r>
+              <a:rPr lang="en-US" b="1" cap="small" dirty="0"/>
+              <a:t>	Quality</a:t>
+            </a:r>
+          </a:p>
+          <a:p>
+            <a:pPr marL="1657350" lvl="3" indent="-285750">
+              <a:buFont typeface="Arial" panose="020B0604020202020204" pitchFamily="34" charset="0"/>
+              <a:buChar char="•"/>
+            </a:pPr>
+            <a:r>
+              <a:rPr lang="en-US" dirty="0"/>
+              <a:t>Release wheel v1.1 publishing on </a:t>
+            </a:r>
+            <a:r>
+              <a:rPr lang="en-US" i="1" dirty="0"/>
+              <a:t>Python Package Index (</a:t>
+            </a:r>
+            <a:r>
+              <a:rPr lang="en-US" i="1" dirty="0" err="1"/>
+              <a:t>PyPI</a:t>
+            </a:r>
+            <a:r>
+              <a:rPr lang="en-US" i="1" dirty="0"/>
+              <a:t>)</a:t>
+            </a:r>
+            <a:r>
+              <a:rPr lang="en-US" i="1" dirty="0">
+                <a:solidFill>
+                  <a:srgbClr val="C00000"/>
+                </a:solidFill>
+              </a:rPr>
+              <a:t>	</a:t>
+            </a:r>
+            <a:r>
+              <a:rPr lang="en-US" dirty="0">
+                <a:solidFill>
+                  <a:srgbClr val="C00000"/>
+                </a:solidFill>
+              </a:rPr>
+              <a:t>[TBD]</a:t>
+            </a:r>
+            <a:endParaRPr lang="en-US" i="1" dirty="0">
+              <a:solidFill>
+                <a:srgbClr val="C00000"/>
+              </a:solidFill>
+            </a:endParaRPr>
+          </a:p>
+          <a:p>
+            <a:r>
+              <a:rPr lang="en-US" b="1" cap="small" dirty="0"/>
+              <a:t>	Perturbations</a:t>
+            </a:r>
+          </a:p>
+          <a:p>
+            <a:pPr marL="1657350" lvl="3" indent="-285750">
+              <a:buFont typeface="Arial" panose="020B0604020202020204" pitchFamily="34" charset="0"/>
+              <a:buChar char="•"/>
+            </a:pPr>
+            <a:r>
+              <a:rPr lang="en-US" dirty="0"/>
+              <a:t>Release wheel v1.1 publishing on </a:t>
+            </a:r>
+            <a:r>
+              <a:rPr lang="en-US" i="1" dirty="0"/>
+              <a:t>Python Package Index (</a:t>
+            </a:r>
+            <a:r>
+              <a:rPr lang="en-US" i="1" dirty="0" err="1"/>
+              <a:t>PyPI</a:t>
+            </a:r>
+            <a:r>
+              <a:rPr lang="en-US" i="1" dirty="0"/>
+              <a:t>)</a:t>
+            </a:r>
+            <a:r>
+              <a:rPr lang="en-US" i="1" dirty="0">
+                <a:solidFill>
+                  <a:srgbClr val="C00000"/>
+                </a:solidFill>
+              </a:rPr>
+              <a:t>	</a:t>
+            </a:r>
+            <a:r>
+              <a:rPr lang="en-US" dirty="0">
+                <a:solidFill>
+                  <a:srgbClr val="C00000"/>
+                </a:solidFill>
+              </a:rPr>
+              <a:t>[TBD]</a:t>
+            </a:r>
+            <a:endParaRPr lang="en-US" i="1" dirty="0"/>
+          </a:p>
+          <a:p>
+            <a:pPr lvl="3"/>
+            <a:endParaRPr lang="en-US" dirty="0">
+              <a:solidFill>
+                <a:srgbClr val="C00000"/>
+              </a:solidFill>
+            </a:endParaRPr>
+          </a:p>
+        </p:txBody>
+      </p:sp>
+      <p:sp>
+        <p:nvSpPr>
+          <p:cNvPr id="8" name="TextBox 7">
+            <a:extLst>
+              <a:ext uri="{FF2B5EF4-FFF2-40B4-BE49-F238E27FC236}">
+                <a16:creationId xmlns:a16="http://schemas.microsoft.com/office/drawing/2014/main" id="{F2CB62A5-28A3-DC91-954B-F04A7E97FBD4}"/>
               </a:ext>
             </a:extLst>
           </p:cNvPr>
@@ -12116,18 +12188,13 @@
         </p:nvSpPr>
         <p:spPr>
           <a:xfrm>
-            <a:off x="3054220" y="1239712"/>
-            <a:ext cx="6083559" cy="646331"/>
+            <a:off x="979711" y="1553358"/>
+            <a:ext cx="10795519" cy="646331"/>
           </a:xfrm>
           <a:prstGeom prst="rect">
             <a:avLst/>
           </a:prstGeom>
           <a:noFill/>
-          <a:ln w="38100">
-            <a:solidFill>
-              <a:srgbClr val="FF0000"/>
-            </a:solidFill>
-          </a:ln>
         </p:spPr>
         <p:txBody>
           <a:bodyPr wrap="square" rtlCol="0">
@@ -12135,15 +12202,119 @@
           </a:bodyPr>
           <a:lstStyle/>
           <a:p>
-            <a:pPr algn="ctr"/>
-            <a:r>
-              <a:rPr lang="en-US" sz="3600" b="1" dirty="0">
+            <a:r>
+              <a:rPr lang="en-US" b="1" cap="small" dirty="0" err="1"/>
+              <a:t>Arepytools</a:t>
+            </a:r>
+            <a:endParaRPr lang="en-US" b="1" cap="small" dirty="0"/>
+          </a:p>
+          <a:p>
+            <a:pPr marL="285750" indent="-285750">
+              <a:buFont typeface="Arial" panose="020B0604020202020204" pitchFamily="34" charset="0"/>
+              <a:buChar char="•"/>
+            </a:pPr>
+            <a:r>
+              <a:rPr lang="en-US" dirty="0"/>
+              <a:t>Release wheel v1.6.0 publishing on </a:t>
+            </a:r>
+            <a:r>
+              <a:rPr lang="en-US" i="1" dirty="0"/>
+              <a:t>Python Package Index (</a:t>
+            </a:r>
+            <a:r>
+              <a:rPr lang="en-US" i="1" dirty="0" err="1"/>
+              <a:t>PyPI</a:t>
+            </a:r>
+            <a:r>
+              <a:rPr lang="en-US" i="1" dirty="0"/>
+              <a:t>)			</a:t>
+            </a:r>
+            <a:r>
+              <a:rPr lang="en-US" dirty="0">
                 <a:solidFill>
                   <a:srgbClr val="C00000"/>
                 </a:solidFill>
-                <a:latin typeface="Amasis MT Pro Black" panose="020F0502020204030204" pitchFamily="18" charset="0"/>
               </a:rPr>
-              <a:t>INFORMATION NEEDED</a:t>
+              <a:t>[TBD]</a:t>
+            </a:r>
+          </a:p>
+        </p:txBody>
+      </p:sp>
+      <p:sp>
+        <p:nvSpPr>
+          <p:cNvPr id="9" name="TextBox 8">
+            <a:extLst>
+              <a:ext uri="{FF2B5EF4-FFF2-40B4-BE49-F238E27FC236}">
+                <a16:creationId xmlns:a16="http://schemas.microsoft.com/office/drawing/2014/main" id="{DB88366A-867E-0FC6-09B2-2DF8BB3E76E9}"/>
+              </a:ext>
+            </a:extLst>
+          </p:cNvPr>
+          <p:cNvSpPr txBox="1"/>
+          <p:nvPr/>
+        </p:nvSpPr>
+        <p:spPr>
+          <a:xfrm>
+            <a:off x="979712" y="4426505"/>
+            <a:ext cx="10795519" cy="923330"/>
+          </a:xfrm>
+          <a:prstGeom prst="rect">
+            <a:avLst/>
+          </a:prstGeom>
+          <a:noFill/>
+        </p:spPr>
+        <p:txBody>
+          <a:bodyPr wrap="square" rtlCol="0">
+            <a:spAutoFit/>
+          </a:bodyPr>
+          <a:lstStyle/>
+          <a:p>
+            <a:r>
+              <a:rPr lang="en-US" b="1" cap="small" dirty="0"/>
+              <a:t>SCT</a:t>
+            </a:r>
+          </a:p>
+          <a:p>
+            <a:pPr marL="285750" indent="-285750">
+              <a:buFont typeface="Arial" panose="020B0604020202020204" pitchFamily="34" charset="0"/>
+              <a:buChar char="•"/>
+            </a:pPr>
+            <a:r>
+              <a:rPr lang="en-US" dirty="0"/>
+              <a:t>Create new public </a:t>
+            </a:r>
+            <a:r>
+              <a:rPr lang="en-US" dirty="0" err="1"/>
+              <a:t>github</a:t>
+            </a:r>
+            <a:r>
+              <a:rPr lang="en-US" dirty="0"/>
+              <a:t> repository						</a:t>
+            </a:r>
+            <a:r>
+              <a:rPr lang="en-US" dirty="0">
+                <a:solidFill>
+                  <a:srgbClr val="C00000"/>
+                </a:solidFill>
+              </a:rPr>
+              <a:t>[TBD]</a:t>
+            </a:r>
+          </a:p>
+          <a:p>
+            <a:pPr marL="285750" indent="-285750">
+              <a:buFont typeface="Arial" panose="020B0604020202020204" pitchFamily="34" charset="0"/>
+              <a:buChar char="•"/>
+            </a:pPr>
+            <a:r>
+              <a:rPr lang="en-US" dirty="0"/>
+              <a:t>Release SCT side of project as open-source code and pre-built docker image	</a:t>
+            </a:r>
+            <a:r>
+              <a:rPr lang="en-US" dirty="0">
+                <a:solidFill>
+                  <a:srgbClr val="C00000"/>
+                </a:solidFill>
+              </a:rPr>
+              <a:t>[TBD]</a:t>
             </a:r>
           </a:p>
         </p:txBody>
@@ -12151,7 +12322,7 @@
     </p:spTree>
     <p:extLst>
       <p:ext uri="{BB962C8B-B14F-4D97-AF65-F5344CB8AC3E}">
-        <p14:creationId xmlns:p14="http://schemas.microsoft.com/office/powerpoint/2010/main" val="3641827516"/>
+        <p14:creationId xmlns:p14="http://schemas.microsoft.com/office/powerpoint/2010/main" val="3753827645"/>
       </p:ext>
     </p:extLst>
   </p:cSld>
@@ -12180,358 +12351,6 @@
       </p:grpSpPr>
       <p:sp>
         <p:nvSpPr>
-          <p:cNvPr id="2" name="Title 1">
-            <a:extLst>
-              <a:ext uri="{FF2B5EF4-FFF2-40B4-BE49-F238E27FC236}">
-                <a16:creationId xmlns:a16="http://schemas.microsoft.com/office/drawing/2014/main" id="{CFACDA59-55A0-4EA5-B3E4-646D1D3B4CEB}"/>
-              </a:ext>
-            </a:extLst>
-          </p:cNvPr>
-          <p:cNvSpPr>
-            <a:spLocks noGrp="1"/>
-          </p:cNvSpPr>
-          <p:nvPr>
-            <p:ph type="title"/>
-          </p:nvPr>
-        </p:nvSpPr>
-        <p:spPr>
-          <a:xfrm>
-            <a:off x="839788" y="365125"/>
-            <a:ext cx="10515600" cy="605259"/>
-          </a:xfrm>
-        </p:spPr>
-        <p:txBody>
-          <a:bodyPr>
-            <a:noAutofit/>
-          </a:bodyPr>
-          <a:lstStyle/>
-          <a:p>
-            <a:r>
-              <a:rPr lang="en-US" sz="3600" cap="small" dirty="0"/>
-              <a:t>Public Side </a:t>
-            </a:r>
-            <a:r>
-              <a:rPr lang="en-US" sz="3600" dirty="0"/>
-              <a:t>– Status Updates</a:t>
-            </a:r>
-          </a:p>
-        </p:txBody>
-      </p:sp>
-      <p:sp>
-        <p:nvSpPr>
-          <p:cNvPr id="3" name="TextBox 2">
-            <a:extLst>
-              <a:ext uri="{FF2B5EF4-FFF2-40B4-BE49-F238E27FC236}">
-                <a16:creationId xmlns:a16="http://schemas.microsoft.com/office/drawing/2014/main" id="{585FE47C-A4FF-D018-2E69-4649505A0101}"/>
-              </a:ext>
-            </a:extLst>
-          </p:cNvPr>
-          <p:cNvSpPr txBox="1"/>
-          <p:nvPr/>
-        </p:nvSpPr>
-        <p:spPr>
-          <a:xfrm>
-            <a:off x="979712" y="2672179"/>
-            <a:ext cx="10795519" cy="1754326"/>
-          </a:xfrm>
-          <a:prstGeom prst="rect">
-            <a:avLst/>
-          </a:prstGeom>
-          <a:noFill/>
-        </p:spPr>
-        <p:txBody>
-          <a:bodyPr wrap="square" rtlCol="0">
-            <a:spAutoFit/>
-          </a:bodyPr>
-          <a:lstStyle/>
-          <a:p>
-            <a:r>
-              <a:rPr lang="en-US" b="1" cap="small" dirty="0" err="1"/>
-              <a:t>Arepyextras</a:t>
-            </a:r>
-            <a:endParaRPr lang="en-US" b="1" cap="small" dirty="0"/>
-          </a:p>
-          <a:p>
-            <a:r>
-              <a:rPr lang="en-US" b="1" cap="small" dirty="0"/>
-              <a:t>	Quality</a:t>
-            </a:r>
-          </a:p>
-          <a:p>
-            <a:pPr marL="1657350" lvl="3" indent="-285750">
-              <a:buFont typeface="Arial" panose="020B0604020202020204" pitchFamily="34" charset="0"/>
-              <a:buChar char="•"/>
-            </a:pPr>
-            <a:r>
-              <a:rPr lang="en-US" dirty="0"/>
-              <a:t>Release wheel v1.1 publishing on </a:t>
-            </a:r>
-            <a:r>
-              <a:rPr lang="en-US" i="1" dirty="0"/>
-              <a:t>Python Package Index (</a:t>
-            </a:r>
-            <a:r>
-              <a:rPr lang="en-US" i="1" dirty="0" err="1"/>
-              <a:t>PyPI</a:t>
-            </a:r>
-            <a:r>
-              <a:rPr lang="en-US" i="1" dirty="0"/>
-              <a:t>)</a:t>
-            </a:r>
-            <a:r>
-              <a:rPr lang="en-US" i="1" dirty="0">
-                <a:solidFill>
-                  <a:srgbClr val="C00000"/>
-                </a:solidFill>
-              </a:rPr>
-              <a:t>	</a:t>
-            </a:r>
-            <a:r>
-              <a:rPr lang="en-US" dirty="0">
-                <a:solidFill>
-                  <a:srgbClr val="C00000"/>
-                </a:solidFill>
-              </a:rPr>
-              <a:t>[TBD]</a:t>
-            </a:r>
-            <a:endParaRPr lang="en-US" i="1" dirty="0">
-              <a:solidFill>
-                <a:srgbClr val="C00000"/>
-              </a:solidFill>
-            </a:endParaRPr>
-          </a:p>
-          <a:p>
-            <a:r>
-              <a:rPr lang="en-US" b="1" cap="small" dirty="0"/>
-              <a:t>	Perturbations</a:t>
-            </a:r>
-          </a:p>
-          <a:p>
-            <a:pPr marL="1657350" lvl="3" indent="-285750">
-              <a:buFont typeface="Arial" panose="020B0604020202020204" pitchFamily="34" charset="0"/>
-              <a:buChar char="•"/>
-            </a:pPr>
-            <a:r>
-              <a:rPr lang="en-US" dirty="0"/>
-              <a:t>Release wheel v1.1 publishing on </a:t>
-            </a:r>
-            <a:r>
-              <a:rPr lang="en-US" i="1" dirty="0"/>
-              <a:t>Python Package Index (</a:t>
-            </a:r>
-            <a:r>
-              <a:rPr lang="en-US" i="1" dirty="0" err="1"/>
-              <a:t>PyPI</a:t>
-            </a:r>
-            <a:r>
-              <a:rPr lang="en-US" i="1" dirty="0"/>
-              <a:t>)</a:t>
-            </a:r>
-            <a:r>
-              <a:rPr lang="en-US" i="1" dirty="0">
-                <a:solidFill>
-                  <a:srgbClr val="C00000"/>
-                </a:solidFill>
-              </a:rPr>
-              <a:t>	</a:t>
-            </a:r>
-            <a:r>
-              <a:rPr lang="en-US" dirty="0">
-                <a:solidFill>
-                  <a:srgbClr val="C00000"/>
-                </a:solidFill>
-              </a:rPr>
-              <a:t>[TBD]</a:t>
-            </a:r>
-            <a:endParaRPr lang="en-US" i="1" dirty="0"/>
-          </a:p>
-          <a:p>
-            <a:pPr lvl="3"/>
-            <a:endParaRPr lang="en-US" dirty="0">
-              <a:solidFill>
-                <a:srgbClr val="C00000"/>
-              </a:solidFill>
-            </a:endParaRPr>
-          </a:p>
-        </p:txBody>
-      </p:sp>
-      <p:sp>
-        <p:nvSpPr>
-          <p:cNvPr id="8" name="TextBox 7">
-            <a:extLst>
-              <a:ext uri="{FF2B5EF4-FFF2-40B4-BE49-F238E27FC236}">
-                <a16:creationId xmlns:a16="http://schemas.microsoft.com/office/drawing/2014/main" id="{F2CB62A5-28A3-DC91-954B-F04A7E97FBD4}"/>
-              </a:ext>
-            </a:extLst>
-          </p:cNvPr>
-          <p:cNvSpPr txBox="1"/>
-          <p:nvPr/>
-        </p:nvSpPr>
-        <p:spPr>
-          <a:xfrm>
-            <a:off x="979711" y="1553358"/>
-            <a:ext cx="10795519" cy="646331"/>
-          </a:xfrm>
-          <a:prstGeom prst="rect">
-            <a:avLst/>
-          </a:prstGeom>
-          <a:noFill/>
-        </p:spPr>
-        <p:txBody>
-          <a:bodyPr wrap="square" rtlCol="0">
-            <a:spAutoFit/>
-          </a:bodyPr>
-          <a:lstStyle/>
-          <a:p>
-            <a:r>
-              <a:rPr lang="en-US" b="1" cap="small" dirty="0" err="1"/>
-              <a:t>Arepytools</a:t>
-            </a:r>
-            <a:endParaRPr lang="en-US" b="1" cap="small" dirty="0"/>
-          </a:p>
-          <a:p>
-            <a:pPr marL="285750" indent="-285750">
-              <a:buFont typeface="Arial" panose="020B0604020202020204" pitchFamily="34" charset="0"/>
-              <a:buChar char="•"/>
-            </a:pPr>
-            <a:r>
-              <a:rPr lang="en-US" dirty="0"/>
-              <a:t>Release wheel v1.6.0 publishing on </a:t>
-            </a:r>
-            <a:r>
-              <a:rPr lang="en-US" i="1" dirty="0"/>
-              <a:t>Python Package Index (</a:t>
-            </a:r>
-            <a:r>
-              <a:rPr lang="en-US" i="1" dirty="0" err="1"/>
-              <a:t>PyPI</a:t>
-            </a:r>
-            <a:r>
-              <a:rPr lang="en-US" i="1" dirty="0"/>
-              <a:t>)			</a:t>
-            </a:r>
-            <a:r>
-              <a:rPr lang="en-US" dirty="0">
-                <a:solidFill>
-                  <a:srgbClr val="C00000"/>
-                </a:solidFill>
-              </a:rPr>
-              <a:t>[TBD]</a:t>
-            </a:r>
-          </a:p>
-        </p:txBody>
-      </p:sp>
-      <p:sp>
-        <p:nvSpPr>
-          <p:cNvPr id="9" name="TextBox 8">
-            <a:extLst>
-              <a:ext uri="{FF2B5EF4-FFF2-40B4-BE49-F238E27FC236}">
-                <a16:creationId xmlns:a16="http://schemas.microsoft.com/office/drawing/2014/main" id="{DB88366A-867E-0FC6-09B2-2DF8BB3E76E9}"/>
-              </a:ext>
-            </a:extLst>
-          </p:cNvPr>
-          <p:cNvSpPr txBox="1"/>
-          <p:nvPr/>
-        </p:nvSpPr>
-        <p:spPr>
-          <a:xfrm>
-            <a:off x="979712" y="4426505"/>
-            <a:ext cx="10795519" cy="923330"/>
-          </a:xfrm>
-          <a:prstGeom prst="rect">
-            <a:avLst/>
-          </a:prstGeom>
-          <a:noFill/>
-        </p:spPr>
-        <p:txBody>
-          <a:bodyPr wrap="square" rtlCol="0">
-            <a:spAutoFit/>
-          </a:bodyPr>
-          <a:lstStyle/>
-          <a:p>
-            <a:r>
-              <a:rPr lang="en-US" b="1" cap="small" dirty="0"/>
-              <a:t>SCT</a:t>
-            </a:r>
-          </a:p>
-          <a:p>
-            <a:pPr marL="285750" indent="-285750">
-              <a:buFont typeface="Arial" panose="020B0604020202020204" pitchFamily="34" charset="0"/>
-              <a:buChar char="•"/>
-            </a:pPr>
-            <a:r>
-              <a:rPr lang="en-US" dirty="0"/>
-              <a:t>Create new public </a:t>
-            </a:r>
-            <a:r>
-              <a:rPr lang="en-US" dirty="0" err="1"/>
-              <a:t>github</a:t>
-            </a:r>
-            <a:r>
-              <a:rPr lang="en-US" dirty="0"/>
-              <a:t> repository						</a:t>
-            </a:r>
-            <a:r>
-              <a:rPr lang="en-US" dirty="0">
-                <a:solidFill>
-                  <a:srgbClr val="C00000"/>
-                </a:solidFill>
-              </a:rPr>
-              <a:t>[TBD]</a:t>
-            </a:r>
-          </a:p>
-          <a:p>
-            <a:pPr marL="285750" indent="-285750">
-              <a:buFont typeface="Arial" panose="020B0604020202020204" pitchFamily="34" charset="0"/>
-              <a:buChar char="•"/>
-            </a:pPr>
-            <a:r>
-              <a:rPr lang="en-US" dirty="0"/>
-              <a:t>Release SCT side of project as open-source code and pre-built docker image	</a:t>
-            </a:r>
-            <a:r>
-              <a:rPr lang="en-US" dirty="0">
-                <a:solidFill>
-                  <a:srgbClr val="C00000"/>
-                </a:solidFill>
-              </a:rPr>
-              <a:t>[TBD]</a:t>
-            </a:r>
-          </a:p>
-        </p:txBody>
-      </p:sp>
-    </p:spTree>
-    <p:extLst>
-      <p:ext uri="{BB962C8B-B14F-4D97-AF65-F5344CB8AC3E}">
-        <p14:creationId xmlns:p14="http://schemas.microsoft.com/office/powerpoint/2010/main" val="3753827645"/>
-      </p:ext>
-    </p:extLst>
-  </p:cSld>
-  <p:clrMapOvr>
-    <a:masterClrMapping/>
-  </p:clrMapOvr>
-</p:sld>
-</file>
-
-<file path=ppt/slides/slide15.xml><?xml version="1.0" encoding="utf-8"?>
-<p:sld xmlns:a="http://schemas.openxmlformats.org/drawingml/2006/main" xmlns:r="http://schemas.openxmlformats.org/officeDocument/2006/relationships" xmlns:p="http://schemas.openxmlformats.org/presentationml/2006/main">
-  <p:cSld>
-    <p:spTree>
-      <p:nvGrpSpPr>
-        <p:cNvPr id="1" name=""/>
-        <p:cNvGrpSpPr/>
-        <p:nvPr/>
-      </p:nvGrpSpPr>
-      <p:grpSpPr>
-        <a:xfrm>
-          <a:off x="0" y="0"/>
-          <a:ext cx="0" cy="0"/>
-          <a:chOff x="0" y="0"/>
-          <a:chExt cx="0" cy="0"/>
-        </a:xfrm>
-      </p:grpSpPr>
-      <p:sp>
-        <p:nvSpPr>
           <p:cNvPr id="22" name="Date Placeholder 21">
             <a:extLst>
               <a:ext uri="{FF2B5EF4-FFF2-40B4-BE49-F238E27FC236}">
@@ -12582,7 +12401,7 @@
             <a:fld id="{D8DA9DAA-006C-4F4B-980E-E3DF019B24E2}" type="slidenum">
               <a:rPr lang="en-US" smtClean="0"/>
               <a:pPr/>
-              <a:t>15</a:t>
+              <a:t>14</a:t>
             </a:fld>
             <a:endParaRPr lang="en-US" dirty="0"/>
           </a:p>
@@ -12780,7 +12599,7 @@
 </file>
 
 <file path=ppt/slides/slide2.xml><?xml version="1.0" encoding="utf-8"?>
-<p:sld xmlns:a="http://schemas.openxmlformats.org/drawingml/2006/main" xmlns:r="http://schemas.openxmlformats.org/officeDocument/2006/relationships" xmlns:p="http://schemas.openxmlformats.org/presentationml/2006/main">
+<p:sld xmlns:a="http://schemas.openxmlformats.org/drawingml/2006/main" xmlns:r="http://schemas.openxmlformats.org/officeDocument/2006/relationships" xmlns:p="http://schemas.openxmlformats.org/presentationml/2006/main" show="0">
   <p:cSld>
     <p:spTree>
       <p:nvGrpSpPr>
@@ -12981,7 +12800,7 @@
         <p:spPr>
           <a:xfrm>
             <a:off x="2317108" y="2823306"/>
-            <a:ext cx="2021629" cy="338554"/>
+            <a:ext cx="2290505" cy="338554"/>
           </a:xfrm>
           <a:prstGeom prst="rect">
             <a:avLst/>
@@ -12996,7 +12815,7 @@
           <a:p>
             <a:r>
               <a:rPr lang="en-US" sz="1600" b="1" dirty="0"/>
-              <a:t>perturbations</a:t>
+              <a:t>Perturbations (1.1.0)</a:t>
             </a:r>
             <a:endParaRPr lang="en-US" sz="1600" dirty="0"/>
           </a:p>
@@ -13017,7 +12836,7 @@
         <p:spPr>
           <a:xfrm>
             <a:off x="2317107" y="3213399"/>
-            <a:ext cx="1825687" cy="338554"/>
+            <a:ext cx="2401164" cy="338554"/>
           </a:xfrm>
           <a:prstGeom prst="rect">
             <a:avLst/>
@@ -13034,6 +12853,10 @@
               <a:rPr lang="en-US" sz="1600" b="1" dirty="0" err="1"/>
               <a:t>iers_solid_tides</a:t>
             </a:r>
+            <a:r>
+              <a:rPr lang="en-US" sz="1600" b="1" dirty="0"/>
+              <a:t> (1.0.0)</a:t>
+            </a:r>
             <a:endParaRPr lang="en-US" sz="1600" dirty="0"/>
           </a:p>
         </p:txBody>
@@ -13068,7 +12891,7 @@
           <a:p>
             <a:r>
               <a:rPr lang="en-US" sz="1600" b="1" dirty="0"/>
-              <a:t>quality</a:t>
+              <a:t>quality (1.1.0)</a:t>
             </a:r>
             <a:endParaRPr lang="en-US" sz="1600" dirty="0"/>
           </a:p>
@@ -13089,7 +12912,7 @@
         <p:spPr>
           <a:xfrm>
             <a:off x="2317107" y="3986929"/>
-            <a:ext cx="1825688" cy="338554"/>
+            <a:ext cx="2122336" cy="338554"/>
           </a:xfrm>
           <a:prstGeom prst="rect">
             <a:avLst/>
@@ -13105,6 +12928,10 @@
             <a:r>
               <a:rPr lang="en-US" sz="1600" b="1" dirty="0" err="1"/>
               <a:t>eo_products</a:t>
+            </a:r>
+            <a:r>
+              <a:rPr lang="en-US" sz="1600" b="1" dirty="0"/>
+              <a:t> (1.0.0)</a:t>
             </a:r>
             <a:endParaRPr lang="en-US" sz="1600" i="1" dirty="0">
               <a:solidFill>
@@ -14543,10 +14370,10 @@
       </p:sp>
       <p:pic>
         <p:nvPicPr>
-          <p:cNvPr id="7" name="Picture 6" descr="A screen shot of a computer&#10;&#10;Description automatically generated">
-            <a:extLst>
-              <a:ext uri="{FF2B5EF4-FFF2-40B4-BE49-F238E27FC236}">
-                <a16:creationId xmlns:a16="http://schemas.microsoft.com/office/drawing/2014/main" id="{9C48B7BE-7647-80AF-9AB2-12AE1D5FFC41}"/>
+          <p:cNvPr id="4" name="Picture 3" descr="A diagram of a diagram&#10;&#10;Description automatically generated">
+            <a:extLst>
+              <a:ext uri="{FF2B5EF4-FFF2-40B4-BE49-F238E27FC236}">
+                <a16:creationId xmlns:a16="http://schemas.microsoft.com/office/drawing/2014/main" id="{040429A6-281E-2D71-8413-1B1A515B97D7}"/>
               </a:ext>
             </a:extLst>
           </p:cNvPr>
@@ -14563,14 +14390,49 @@
         </p:blipFill>
         <p:spPr>
           <a:xfrm>
-            <a:off x="1156153" y="970384"/>
-            <a:ext cx="9879693" cy="5716344"/>
+            <a:off x="1713852" y="1156438"/>
+            <a:ext cx="8793122" cy="5467118"/>
           </a:xfrm>
           <a:prstGeom prst="rect">
             <a:avLst/>
           </a:prstGeom>
         </p:spPr>
       </p:pic>
+      <p:sp>
+        <p:nvSpPr>
+          <p:cNvPr id="3" name="TextBox 2">
+            <a:extLst>
+              <a:ext uri="{FF2B5EF4-FFF2-40B4-BE49-F238E27FC236}">
+                <a16:creationId xmlns:a16="http://schemas.microsoft.com/office/drawing/2014/main" id="{0B78A589-559E-9E20-AC5F-62A8C9D09FAA}"/>
+              </a:ext>
+            </a:extLst>
+          </p:cNvPr>
+          <p:cNvSpPr txBox="1"/>
+          <p:nvPr/>
+        </p:nvSpPr>
+        <p:spPr>
+          <a:xfrm>
+            <a:off x="8307237" y="4597880"/>
+            <a:ext cx="560717" cy="646331"/>
+          </a:xfrm>
+          <a:prstGeom prst="rect">
+            <a:avLst/>
+          </a:prstGeom>
+          <a:noFill/>
+        </p:spPr>
+        <p:txBody>
+          <a:bodyPr wrap="square" rtlCol="0">
+            <a:spAutoFit/>
+          </a:bodyPr>
+          <a:lstStyle/>
+          <a:p>
+            <a:r>
+              <a:rPr lang="en-US" sz="3600" b="1" dirty="0"/>
+              <a:t>?</a:t>
+            </a:r>
+          </a:p>
+        </p:txBody>
+      </p:sp>
     </p:spTree>
     <p:extLst>
       <p:ext uri="{BB962C8B-B14F-4D97-AF65-F5344CB8AC3E}">
@@ -14630,6 +14492,191 @@
           <a:lstStyle/>
           <a:p>
             <a:r>
+              <a:rPr lang="en-US" sz="3200" dirty="0"/>
+              <a:t>High Level Software Architecture - </a:t>
+            </a:r>
+            <a:r>
+              <a:rPr lang="en-US" sz="3200" dirty="0" err="1"/>
+              <a:t>Arepyextras</a:t>
+            </a:r>
+            <a:endParaRPr lang="en-US" sz="3200" dirty="0"/>
+          </a:p>
+        </p:txBody>
+      </p:sp>
+      <p:pic>
+        <p:nvPicPr>
+          <p:cNvPr id="4" name="Picture 3" descr="A screenshot of a diagram&#10;&#10;Description automatically generated">
+            <a:extLst>
+              <a:ext uri="{FF2B5EF4-FFF2-40B4-BE49-F238E27FC236}">
+                <a16:creationId xmlns:a16="http://schemas.microsoft.com/office/drawing/2014/main" id="{232D7DD6-3522-C987-C816-162443DA39FA}"/>
+              </a:ext>
+            </a:extLst>
+          </p:cNvPr>
+          <p:cNvPicPr>
+            <a:picLocks noChangeAspect="1"/>
+          </p:cNvPicPr>
+          <p:nvPr/>
+        </p:nvPicPr>
+        <p:blipFill>
+          <a:blip r:embed="rId2"/>
+          <a:stretch>
+            <a:fillRect/>
+          </a:stretch>
+        </p:blipFill>
+        <p:spPr>
+          <a:xfrm>
+            <a:off x="923176" y="1108406"/>
+            <a:ext cx="10432212" cy="5532354"/>
+          </a:xfrm>
+          <a:prstGeom prst="rect">
+            <a:avLst/>
+          </a:prstGeom>
+        </p:spPr>
+      </p:pic>
+      <p:sp>
+        <p:nvSpPr>
+          <p:cNvPr id="5" name="Rectangle 4">
+            <a:extLst>
+              <a:ext uri="{FF2B5EF4-FFF2-40B4-BE49-F238E27FC236}">
+                <a16:creationId xmlns:a16="http://schemas.microsoft.com/office/drawing/2014/main" id="{49CC7969-F2A6-6C45-A463-E0F3A96C75E0}"/>
+              </a:ext>
+            </a:extLst>
+          </p:cNvPr>
+          <p:cNvSpPr/>
+          <p:nvPr/>
+        </p:nvSpPr>
+        <p:spPr>
+          <a:xfrm>
+            <a:off x="1414732" y="1639019"/>
+            <a:ext cx="9601200" cy="2562045"/>
+          </a:xfrm>
+          <a:prstGeom prst="rect">
+            <a:avLst/>
+          </a:prstGeom>
+          <a:noFill/>
+          <a:ln w="28575">
+            <a:prstDash val="lgDash"/>
+          </a:ln>
+        </p:spPr>
+        <p:style>
+          <a:lnRef idx="2">
+            <a:schemeClr val="accent1">
+              <a:shade val="15000"/>
+            </a:schemeClr>
+          </a:lnRef>
+          <a:fillRef idx="1">
+            <a:schemeClr val="accent1"/>
+          </a:fillRef>
+          <a:effectRef idx="0">
+            <a:schemeClr val="accent1"/>
+          </a:effectRef>
+          <a:fontRef idx="minor">
+            <a:schemeClr val="lt1"/>
+          </a:fontRef>
+        </p:style>
+        <p:txBody>
+          <a:bodyPr rtlCol="0" anchor="ctr"/>
+          <a:lstStyle/>
+          <a:p>
+            <a:pPr algn="ctr"/>
+            <a:endParaRPr lang="en-US"/>
+          </a:p>
+        </p:txBody>
+      </p:sp>
+      <p:sp>
+        <p:nvSpPr>
+          <p:cNvPr id="6" name="TextBox 5">
+            <a:extLst>
+              <a:ext uri="{FF2B5EF4-FFF2-40B4-BE49-F238E27FC236}">
+                <a16:creationId xmlns:a16="http://schemas.microsoft.com/office/drawing/2014/main" id="{872BDB1F-4187-F1C0-0940-A1D477F1441D}"/>
+              </a:ext>
+            </a:extLst>
+          </p:cNvPr>
+          <p:cNvSpPr txBox="1"/>
+          <p:nvPr/>
+        </p:nvSpPr>
+        <p:spPr>
+          <a:xfrm>
+            <a:off x="8902460" y="1269687"/>
+            <a:ext cx="2717321" cy="369332"/>
+          </a:xfrm>
+          <a:prstGeom prst="rect">
+            <a:avLst/>
+          </a:prstGeom>
+          <a:noFill/>
+        </p:spPr>
+        <p:txBody>
+          <a:bodyPr wrap="square" rtlCol="0">
+            <a:spAutoFit/>
+          </a:bodyPr>
+          <a:lstStyle/>
+          <a:p>
+            <a:r>
+              <a:rPr lang="en-US" dirty="0"/>
+              <a:t>SCT Dependencies</a:t>
+            </a:r>
+          </a:p>
+        </p:txBody>
+      </p:sp>
+    </p:spTree>
+    <p:extLst>
+      <p:ext uri="{BB962C8B-B14F-4D97-AF65-F5344CB8AC3E}">
+        <p14:creationId xmlns:p14="http://schemas.microsoft.com/office/powerpoint/2010/main" val="1254159667"/>
+      </p:ext>
+    </p:extLst>
+  </p:cSld>
+  <p:clrMapOvr>
+    <a:masterClrMapping/>
+  </p:clrMapOvr>
+</p:sld>
+</file>
+
+<file path=ppt/slides/slide5.xml><?xml version="1.0" encoding="utf-8"?>
+<p:sld xmlns:a="http://schemas.openxmlformats.org/drawingml/2006/main" xmlns:r="http://schemas.openxmlformats.org/officeDocument/2006/relationships" xmlns:p="http://schemas.openxmlformats.org/presentationml/2006/main">
+  <p:cSld>
+    <p:spTree>
+      <p:nvGrpSpPr>
+        <p:cNvPr id="1" name=""/>
+        <p:cNvGrpSpPr/>
+        <p:nvPr/>
+      </p:nvGrpSpPr>
+      <p:grpSpPr>
+        <a:xfrm>
+          <a:off x="0" y="0"/>
+          <a:ext cx="0" cy="0"/>
+          <a:chOff x="0" y="0"/>
+          <a:chExt cx="0" cy="0"/>
+        </a:xfrm>
+      </p:grpSpPr>
+      <p:sp>
+        <p:nvSpPr>
+          <p:cNvPr id="2" name="Title 1">
+            <a:extLst>
+              <a:ext uri="{FF2B5EF4-FFF2-40B4-BE49-F238E27FC236}">
+                <a16:creationId xmlns:a16="http://schemas.microsoft.com/office/drawing/2014/main" id="{CFACDA59-55A0-4EA5-B3E4-646D1D3B4CEB}"/>
+              </a:ext>
+            </a:extLst>
+          </p:cNvPr>
+          <p:cNvSpPr>
+            <a:spLocks noGrp="1"/>
+          </p:cNvSpPr>
+          <p:nvPr>
+            <p:ph type="title"/>
+          </p:nvPr>
+        </p:nvSpPr>
+        <p:spPr>
+          <a:xfrm>
+            <a:off x="839788" y="365125"/>
+            <a:ext cx="10515600" cy="605259"/>
+          </a:xfrm>
+        </p:spPr>
+        <p:txBody>
+          <a:bodyPr>
+            <a:noAutofit/>
+          </a:bodyPr>
+          <a:lstStyle/>
+          <a:p>
+            <a:r>
               <a:rPr lang="en-US" sz="3600" dirty="0"/>
               <a:t>Supported Missions and Products</a:t>
             </a:r>
@@ -14651,14 +14698,14 @@
           <p:nvPr>
             <p:extLst>
               <p:ext uri="{D42A27DB-BD31-4B8C-83A1-F6EECF244321}">
-                <p14:modId xmlns:p14="http://schemas.microsoft.com/office/powerpoint/2010/main" val="1679364581"/>
+                <p14:modId xmlns:p14="http://schemas.microsoft.com/office/powerpoint/2010/main" val="3642816723"/>
               </p:ext>
             </p:extLst>
           </p:nvPr>
         </p:nvGraphicFramePr>
         <p:xfrm>
-          <a:off x="839788" y="1075715"/>
-          <a:ext cx="10515600" cy="4820920"/>
+          <a:off x="996276" y="1075715"/>
+          <a:ext cx="10199448" cy="4922520"/>
         </p:xfrm>
         <a:graphic>
           <a:graphicData uri="http://schemas.openxmlformats.org/drawingml/2006/table">
@@ -14667,28 +14714,28 @@
                 <a:tableStyleId>{5C22544A-7EE6-4342-B048-85BDC9FD1C3A}</a:tableStyleId>
               </a:tblPr>
               <a:tblGrid>
-                <a:gridCol w="3629609">
+                <a:gridCol w="3520485">
                   <a:extLst>
                     <a:ext uri="{9D8B030D-6E8A-4147-A177-3AD203B41FA5}">
                       <a16:colId xmlns:a16="http://schemas.microsoft.com/office/drawing/2014/main" val="1498214684"/>
                     </a:ext>
                   </a:extLst>
                 </a:gridCol>
-                <a:gridCol w="3331029">
+                <a:gridCol w="3230881">
                   <a:extLst>
                     <a:ext uri="{9D8B030D-6E8A-4147-A177-3AD203B41FA5}">
                       <a16:colId xmlns:a16="http://schemas.microsoft.com/office/drawing/2014/main" val="2269859059"/>
                     </a:ext>
                   </a:extLst>
                 </a:gridCol>
-                <a:gridCol w="2155371">
+                <a:gridCol w="2090570">
                   <a:extLst>
                     <a:ext uri="{9D8B030D-6E8A-4147-A177-3AD203B41FA5}">
                       <a16:colId xmlns:a16="http://schemas.microsoft.com/office/drawing/2014/main" val="3925662890"/>
                     </a:ext>
                   </a:extLst>
                 </a:gridCol>
-                <a:gridCol w="1399591">
+                <a:gridCol w="1357512">
                   <a:extLst>
                     <a:ext uri="{9D8B030D-6E8A-4147-A177-3AD203B41FA5}">
                       <a16:colId xmlns:a16="http://schemas.microsoft.com/office/drawing/2014/main" val="69041804"/>
@@ -14801,11 +14848,42 @@
                     <a:bodyPr/>
                     <a:lstStyle/>
                     <a:p>
-                      <a:pPr algn="ctr"/>
+                      <a:pPr marL="0" marR="0" lvl="0" indent="0" algn="ctr" defTabSz="914400" rtl="0" eaLnBrk="1" fontAlgn="auto" latinLnBrk="0" hangingPunct="1">
+                        <a:lnSpc>
+                          <a:spcPct val="100000"/>
+                        </a:lnSpc>
+                        <a:spcBef>
+                          <a:spcPts val="0"/>
+                        </a:spcBef>
+                        <a:spcAft>
+                          <a:spcPts val="0"/>
+                        </a:spcAft>
+                        <a:buClrTx/>
+                        <a:buSzTx/>
+                        <a:buFontTx/>
+                        <a:buNone/>
+                        <a:tabLst/>
+                        <a:defRPr/>
+                      </a:pPr>
                       <a:r>
-                        <a:rPr lang="en-US" dirty="0"/>
+                        <a:rPr lang="en-US" sz="2000" b="1" kern="1200" dirty="0">
+                          <a:solidFill>
+                            <a:srgbClr val="00B050"/>
+                          </a:solidFill>
+                          <a:latin typeface="+mn-lt"/>
+                          <a:ea typeface="+mn-ea"/>
+                          <a:cs typeface="+mn-cs"/>
+                        </a:rPr>
                         <a:t>DONE</a:t>
                       </a:r>
+                      <a:endParaRPr lang="en-US" sz="1800" b="1" kern="1200" dirty="0">
+                        <a:solidFill>
+                          <a:srgbClr val="00B050"/>
+                        </a:solidFill>
+                        <a:latin typeface="+mn-lt"/>
+                        <a:ea typeface="+mn-ea"/>
+                        <a:cs typeface="+mn-cs"/>
+                      </a:endParaRPr>
                     </a:p>
                   </a:txBody>
                   <a:tcPr/>
@@ -14864,11 +14942,42 @@
                     <a:bodyPr/>
                     <a:lstStyle/>
                     <a:p>
-                      <a:pPr algn="ctr"/>
+                      <a:pPr marL="0" marR="0" lvl="0" indent="0" algn="ctr" defTabSz="914400" rtl="0" eaLnBrk="1" fontAlgn="auto" latinLnBrk="0" hangingPunct="1">
+                        <a:lnSpc>
+                          <a:spcPct val="100000"/>
+                        </a:lnSpc>
+                        <a:spcBef>
+                          <a:spcPts val="0"/>
+                        </a:spcBef>
+                        <a:spcAft>
+                          <a:spcPts val="0"/>
+                        </a:spcAft>
+                        <a:buClrTx/>
+                        <a:buSzTx/>
+                        <a:buFontTx/>
+                        <a:buNone/>
+                        <a:tabLst/>
+                        <a:defRPr/>
+                      </a:pPr>
                       <a:r>
-                        <a:rPr lang="en-US" dirty="0"/>
+                        <a:rPr lang="en-US" sz="2000" b="1" kern="1200" dirty="0">
+                          <a:solidFill>
+                            <a:srgbClr val="00B050"/>
+                          </a:solidFill>
+                          <a:latin typeface="+mn-lt"/>
+                          <a:ea typeface="+mn-ea"/>
+                          <a:cs typeface="+mn-cs"/>
+                        </a:rPr>
                         <a:t>DONE</a:t>
                       </a:r>
+                      <a:endParaRPr lang="en-US" sz="1800" b="1" kern="1200" dirty="0">
+                        <a:solidFill>
+                          <a:srgbClr val="00B050"/>
+                        </a:solidFill>
+                        <a:latin typeface="+mn-lt"/>
+                        <a:ea typeface="+mn-ea"/>
+                        <a:cs typeface="+mn-cs"/>
+                      </a:endParaRPr>
                     </a:p>
                   </a:txBody>
                   <a:tcPr/>
@@ -14933,7 +15042,11 @@
                     <a:p>
                       <a:pPr algn="ctr"/>
                       <a:r>
-                        <a:rPr lang="en-US" dirty="0"/>
+                        <a:rPr lang="en-US" b="1" dirty="0">
+                          <a:solidFill>
+                            <a:srgbClr val="00B0F0"/>
+                          </a:solidFill>
+                        </a:rPr>
                         <a:t>ONGOING</a:t>
                       </a:r>
                     </a:p>
@@ -14998,10 +15111,17 @@
                     <a:bodyPr/>
                     <a:lstStyle/>
                     <a:p>
-                      <a:pPr algn="ctr"/>
+                      <a:pPr marL="0" algn="ctr" defTabSz="914400" rtl="0" eaLnBrk="1" latinLnBrk="0" hangingPunct="1"/>
                       <a:r>
-                        <a:rPr lang="en-US" dirty="0"/>
-                        <a:t>TBD</a:t>
+                        <a:rPr lang="en-US" sz="2000" b="1" kern="1200" dirty="0">
+                          <a:solidFill>
+                            <a:srgbClr val="00B050"/>
+                          </a:solidFill>
+                          <a:latin typeface="+mn-lt"/>
+                          <a:ea typeface="+mn-ea"/>
+                          <a:cs typeface="+mn-cs"/>
+                        </a:rPr>
+                        <a:t>DONE</a:t>
                       </a:r>
                     </a:p>
                   </a:txBody>
@@ -15068,8 +15188,12 @@
                     <a:p>
                       <a:pPr algn="ctr"/>
                       <a:r>
-                        <a:rPr lang="en-US" dirty="0"/>
-                        <a:t>TBD</a:t>
+                        <a:rPr lang="en-US" b="1" dirty="0">
+                          <a:solidFill>
+                            <a:srgbClr val="00B0F0"/>
+                          </a:solidFill>
+                        </a:rPr>
+                        <a:t>ONGOING</a:t>
                       </a:r>
                     </a:p>
                   </a:txBody>
@@ -15136,8 +15260,12 @@
                     <a:p>
                       <a:pPr algn="ctr"/>
                       <a:r>
-                        <a:rPr lang="en-US" dirty="0"/>
-                        <a:t>TBD</a:t>
+                        <a:rPr lang="en-US" sz="2000" b="1" dirty="0">
+                          <a:solidFill>
+                            <a:srgbClr val="00B050"/>
+                          </a:solidFill>
+                        </a:rPr>
+                        <a:t>DONE</a:t>
                       </a:r>
                     </a:p>
                   </a:txBody>
@@ -15592,7 +15720,7 @@
         </p:nvSpPr>
         <p:spPr>
           <a:xfrm>
-            <a:off x="10935476" y="5896635"/>
+            <a:off x="10645217" y="5974448"/>
             <a:ext cx="1101013" cy="523220"/>
           </a:xfrm>
           <a:prstGeom prst="rect">
@@ -15627,329 +15755,84 @@
           </a:p>
         </p:txBody>
       </p:sp>
+      <p:cxnSp>
+        <p:nvCxnSpPr>
+          <p:cNvPr id="4" name="Straight Connector 3">
+            <a:extLst>
+              <a:ext uri="{FF2B5EF4-FFF2-40B4-BE49-F238E27FC236}">
+                <a16:creationId xmlns:a16="http://schemas.microsoft.com/office/drawing/2014/main" id="{CA243906-A7AF-683A-9858-871BD8DB5D31}"/>
+              </a:ext>
+            </a:extLst>
+          </p:cNvPr>
+          <p:cNvCxnSpPr/>
+          <p:nvPr/>
+        </p:nvCxnSpPr>
+        <p:spPr>
+          <a:xfrm>
+            <a:off x="379562" y="3743865"/>
+            <a:ext cx="11366668" cy="0"/>
+          </a:xfrm>
+          <a:prstGeom prst="line">
+            <a:avLst/>
+          </a:prstGeom>
+          <a:ln w="38100">
+            <a:prstDash val="dashDot"/>
+          </a:ln>
+        </p:spPr>
+        <p:style>
+          <a:lnRef idx="1">
+            <a:schemeClr val="dk1"/>
+          </a:lnRef>
+          <a:fillRef idx="0">
+            <a:schemeClr val="dk1"/>
+          </a:fillRef>
+          <a:effectRef idx="0">
+            <a:schemeClr val="dk1"/>
+          </a:effectRef>
+          <a:fontRef idx="minor">
+            <a:schemeClr val="tx1"/>
+          </a:fontRef>
+        </p:style>
+      </p:cxnSp>
+      <p:sp>
+        <p:nvSpPr>
+          <p:cNvPr id="5" name="TextBox 4">
+            <a:extLst>
+              <a:ext uri="{FF2B5EF4-FFF2-40B4-BE49-F238E27FC236}">
+                <a16:creationId xmlns:a16="http://schemas.microsoft.com/office/drawing/2014/main" id="{67A00223-C715-35FE-E25F-9F921A2C1E44}"/>
+              </a:ext>
+            </a:extLst>
+          </p:cNvPr>
+          <p:cNvSpPr txBox="1"/>
+          <p:nvPr/>
+        </p:nvSpPr>
+        <p:spPr>
+          <a:xfrm>
+            <a:off x="10670779" y="3466866"/>
+            <a:ext cx="1141659" cy="276999"/>
+          </a:xfrm>
+          <a:prstGeom prst="rect">
+            <a:avLst/>
+          </a:prstGeom>
+          <a:noFill/>
+        </p:spPr>
+        <p:txBody>
+          <a:bodyPr wrap="none" rtlCol="0">
+            <a:spAutoFit/>
+          </a:bodyPr>
+          <a:lstStyle/>
+          <a:p>
+            <a:r>
+              <a:rPr lang="en-US" sz="1200" b="1" dirty="0"/>
+              <a:t>April Release</a:t>
+            </a:r>
+          </a:p>
+        </p:txBody>
+      </p:sp>
     </p:spTree>
     <p:extLst>
       <p:ext uri="{BB962C8B-B14F-4D97-AF65-F5344CB8AC3E}">
         <p14:creationId xmlns:p14="http://schemas.microsoft.com/office/powerpoint/2010/main" val="2010019361"/>
-      </p:ext>
-    </p:extLst>
-  </p:cSld>
-  <p:clrMapOvr>
-    <a:masterClrMapping/>
-  </p:clrMapOvr>
-</p:sld>
-</file>
-
-<file path=ppt/slides/slide5.xml><?xml version="1.0" encoding="utf-8"?>
-<p:sld xmlns:a="http://schemas.openxmlformats.org/drawingml/2006/main" xmlns:r="http://schemas.openxmlformats.org/officeDocument/2006/relationships" xmlns:p="http://schemas.openxmlformats.org/presentationml/2006/main">
-  <p:cSld>
-    <p:spTree>
-      <p:nvGrpSpPr>
-        <p:cNvPr id="1" name=""/>
-        <p:cNvGrpSpPr/>
-        <p:nvPr/>
-      </p:nvGrpSpPr>
-      <p:grpSpPr>
-        <a:xfrm>
-          <a:off x="0" y="0"/>
-          <a:ext cx="0" cy="0"/>
-          <a:chOff x="0" y="0"/>
-          <a:chExt cx="0" cy="0"/>
-        </a:xfrm>
-      </p:grpSpPr>
-      <p:sp>
-        <p:nvSpPr>
-          <p:cNvPr id="2" name="Title 1">
-            <a:extLst>
-              <a:ext uri="{FF2B5EF4-FFF2-40B4-BE49-F238E27FC236}">
-                <a16:creationId xmlns:a16="http://schemas.microsoft.com/office/drawing/2014/main" id="{CFACDA59-55A0-4EA5-B3E4-646D1D3B4CEB}"/>
-              </a:ext>
-            </a:extLst>
-          </p:cNvPr>
-          <p:cNvSpPr>
-            <a:spLocks noGrp="1"/>
-          </p:cNvSpPr>
-          <p:nvPr>
-            <p:ph type="title"/>
-          </p:nvPr>
-        </p:nvSpPr>
-        <p:spPr>
-          <a:xfrm>
-            <a:off x="839788" y="365125"/>
-            <a:ext cx="10515600" cy="605259"/>
-          </a:xfrm>
-        </p:spPr>
-        <p:txBody>
-          <a:bodyPr>
-            <a:noAutofit/>
-          </a:bodyPr>
-          <a:lstStyle/>
-          <a:p>
-            <a:r>
-              <a:rPr lang="en-US" sz="3600" dirty="0"/>
-              <a:t>OPEN POINT LIST (ESA)</a:t>
-            </a:r>
-          </a:p>
-        </p:txBody>
-      </p:sp>
-      <p:sp>
-        <p:nvSpPr>
-          <p:cNvPr id="4" name="TextBox 3">
-            <a:extLst>
-              <a:ext uri="{FF2B5EF4-FFF2-40B4-BE49-F238E27FC236}">
-                <a16:creationId xmlns:a16="http://schemas.microsoft.com/office/drawing/2014/main" id="{DEC6B50C-B5E2-57CE-3080-D8B6585E35E7}"/>
-              </a:ext>
-            </a:extLst>
-          </p:cNvPr>
-          <p:cNvSpPr txBox="1"/>
-          <p:nvPr/>
-        </p:nvSpPr>
-        <p:spPr>
-          <a:xfrm>
-            <a:off x="1537657" y="1585418"/>
-            <a:ext cx="8003157" cy="4247317"/>
-          </a:xfrm>
-          <a:prstGeom prst="rect">
-            <a:avLst/>
-          </a:prstGeom>
-          <a:noFill/>
-        </p:spPr>
-        <p:txBody>
-          <a:bodyPr wrap="square">
-            <a:spAutoFit/>
-          </a:bodyPr>
-          <a:lstStyle/>
-          <a:p>
-            <a:pPr algn="l"/>
-            <a:r>
-              <a:rPr lang="en-US" b="1" i="0" dirty="0">
-                <a:solidFill>
-                  <a:srgbClr val="000000"/>
-                </a:solidFill>
-                <a:effectLst/>
-                <a:latin typeface="Calibri" panose="020F0502020204030204" pitchFamily="34" charset="0"/>
-              </a:rPr>
-              <a:t>Dear all,</a:t>
-            </a:r>
-          </a:p>
-          <a:p>
-            <a:pPr algn="l"/>
-            <a:r>
-              <a:rPr lang="en-US" b="1" i="0" dirty="0">
-                <a:solidFill>
-                  <a:srgbClr val="000000"/>
-                </a:solidFill>
-                <a:effectLst/>
-                <a:latin typeface="Calibri" panose="020F0502020204030204" pitchFamily="34" charset="0"/>
-              </a:rPr>
-              <a:t>We would like to propose the following list of points for the agenda of the meeting:</a:t>
-            </a:r>
-          </a:p>
-          <a:p>
-            <a:pPr algn="l"/>
-            <a:r>
-              <a:rPr lang="en-US" b="1" i="0" dirty="0">
-                <a:solidFill>
-                  <a:srgbClr val="000000"/>
-                </a:solidFill>
-                <a:effectLst/>
-                <a:latin typeface="Calibri" panose="020F0502020204030204" pitchFamily="34" charset="0"/>
-              </a:rPr>
-              <a:t> </a:t>
-            </a:r>
-          </a:p>
-          <a:p>
-            <a:pPr algn="l">
-              <a:buFont typeface="Arial" panose="020B0604020202020204" pitchFamily="34" charset="0"/>
-              <a:buChar char="•"/>
-            </a:pPr>
-            <a:r>
-              <a:rPr lang="en-US" b="1" i="0" dirty="0">
-                <a:solidFill>
-                  <a:srgbClr val="000000"/>
-                </a:solidFill>
-                <a:effectLst/>
-                <a:latin typeface="Calibri" panose="020F0502020204030204" pitchFamily="34" charset="0"/>
-              </a:rPr>
-              <a:t>Overview of the future development (SAR-MPC)</a:t>
-            </a:r>
-          </a:p>
-          <a:p>
-            <a:pPr marL="742950" lvl="1" indent="-285750" algn="l">
-              <a:buFont typeface="Courier New" panose="02070309020205020404" pitchFamily="49" charset="0"/>
-              <a:buChar char="o"/>
-            </a:pPr>
-            <a:r>
-              <a:rPr lang="en-US" b="1" i="0" dirty="0">
-                <a:solidFill>
-                  <a:srgbClr val="000000"/>
-                </a:solidFill>
-                <a:effectLst/>
-                <a:latin typeface="Calibri" panose="020F0502020204030204" pitchFamily="34" charset="0"/>
-              </a:rPr>
-              <a:t>Features</a:t>
-            </a:r>
-          </a:p>
-          <a:p>
-            <a:pPr marL="742950" lvl="1" indent="-285750" algn="l">
-              <a:buFont typeface="Courier New" panose="02070309020205020404" pitchFamily="49" charset="0"/>
-              <a:buChar char="o"/>
-            </a:pPr>
-            <a:r>
-              <a:rPr lang="en-US" b="1" i="0" dirty="0">
-                <a:solidFill>
-                  <a:srgbClr val="000000"/>
-                </a:solidFill>
-                <a:effectLst/>
-                <a:latin typeface="Calibri" panose="020F0502020204030204" pitchFamily="34" charset="0"/>
-              </a:rPr>
-              <a:t>Architecture</a:t>
-            </a:r>
-          </a:p>
-          <a:p>
-            <a:pPr algn="l">
-              <a:buFont typeface="Arial" panose="020B0604020202020204" pitchFamily="34" charset="0"/>
-              <a:buChar char="•"/>
-            </a:pPr>
-            <a:r>
-              <a:rPr lang="en-US" b="1" i="0" dirty="0" err="1">
-                <a:solidFill>
-                  <a:srgbClr val="000000"/>
-                </a:solidFill>
-                <a:effectLst/>
-                <a:latin typeface="Calibri" panose="020F0502020204030204" pitchFamily="34" charset="0"/>
-              </a:rPr>
-              <a:t>Harmonisation</a:t>
-            </a:r>
-            <a:r>
-              <a:rPr lang="en-US" b="1" i="0" dirty="0">
-                <a:solidFill>
-                  <a:srgbClr val="000000"/>
-                </a:solidFill>
-                <a:effectLst/>
-                <a:latin typeface="Calibri" panose="020F0502020204030204" pitchFamily="34" charset="0"/>
-              </a:rPr>
-              <a:t> with the parallel activities in BIOMASS and EDAP</a:t>
-            </a:r>
-          </a:p>
-          <a:p>
-            <a:pPr marL="742950" lvl="1" indent="-285750" algn="l">
-              <a:buFont typeface="Courier New" panose="02070309020205020404" pitchFamily="49" charset="0"/>
-              <a:buChar char="o"/>
-            </a:pPr>
-            <a:r>
-              <a:rPr lang="en-US" b="1" i="0" dirty="0">
-                <a:solidFill>
-                  <a:srgbClr val="000000"/>
-                </a:solidFill>
-                <a:effectLst/>
-                <a:latin typeface="Calibri" panose="020F0502020204030204" pitchFamily="34" charset="0"/>
-              </a:rPr>
-              <a:t>Clean design and data model</a:t>
-            </a:r>
-          </a:p>
-          <a:p>
-            <a:pPr marL="742950" lvl="1" indent="-285750" algn="l">
-              <a:buFont typeface="Courier New" panose="02070309020205020404" pitchFamily="49" charset="0"/>
-              <a:buChar char="o"/>
-            </a:pPr>
-            <a:r>
-              <a:rPr lang="en-US" b="1" i="0" dirty="0">
-                <a:solidFill>
-                  <a:srgbClr val="000000"/>
-                </a:solidFill>
-                <a:effectLst/>
-                <a:latin typeface="Calibri" panose="020F0502020204030204" pitchFamily="34" charset="0"/>
-              </a:rPr>
-              <a:t>Modularity</a:t>
-            </a:r>
-          </a:p>
-          <a:p>
-            <a:pPr marL="742950" lvl="1" indent="-285750" algn="l">
-              <a:buFont typeface="Courier New" panose="02070309020205020404" pitchFamily="49" charset="0"/>
-              <a:buChar char="o"/>
-            </a:pPr>
-            <a:r>
-              <a:rPr lang="en-US" b="1" i="0" dirty="0">
-                <a:solidFill>
-                  <a:srgbClr val="000000"/>
-                </a:solidFill>
-                <a:effectLst/>
-                <a:latin typeface="Calibri" panose="020F0502020204030204" pitchFamily="34" charset="0"/>
-              </a:rPr>
-              <a:t>Additional features</a:t>
-            </a:r>
-          </a:p>
-          <a:p>
-            <a:pPr algn="l">
-              <a:buFont typeface="Arial" panose="020B0604020202020204" pitchFamily="34" charset="0"/>
-              <a:buChar char="•"/>
-            </a:pPr>
-            <a:r>
-              <a:rPr lang="en-US" b="1" i="0" dirty="0">
-                <a:solidFill>
-                  <a:srgbClr val="000000"/>
-                </a:solidFill>
-                <a:effectLst/>
-                <a:latin typeface="Calibri" panose="020F0502020204030204" pitchFamily="34" charset="0"/>
-              </a:rPr>
-              <a:t>Open source best practices</a:t>
-            </a:r>
-          </a:p>
-          <a:p>
-            <a:pPr marL="742950" lvl="1" indent="-285750" algn="l">
-              <a:buFont typeface="Courier New" panose="02070309020205020404" pitchFamily="49" charset="0"/>
-              <a:buChar char="o"/>
-            </a:pPr>
-            <a:r>
-              <a:rPr lang="en-US" b="1" i="0" dirty="0">
-                <a:solidFill>
-                  <a:srgbClr val="000000"/>
-                </a:solidFill>
-                <a:effectLst/>
-                <a:latin typeface="Calibri" panose="020F0502020204030204" pitchFamily="34" charset="0"/>
-              </a:rPr>
-              <a:t>Open-source and open development</a:t>
-            </a:r>
-          </a:p>
-          <a:p>
-            <a:pPr marL="742950" lvl="1" indent="-285750" algn="l">
-              <a:buFont typeface="Courier New" panose="02070309020205020404" pitchFamily="49" charset="0"/>
-              <a:buChar char="o"/>
-            </a:pPr>
-            <a:r>
-              <a:rPr lang="en-US" b="1" i="0" dirty="0">
-                <a:solidFill>
-                  <a:srgbClr val="000000"/>
-                </a:solidFill>
-                <a:effectLst/>
-                <a:latin typeface="Calibri" panose="020F0502020204030204" pitchFamily="34" charset="0"/>
-              </a:rPr>
-              <a:t>Code quality</a:t>
-            </a:r>
-          </a:p>
-          <a:p>
-            <a:pPr marL="742950" lvl="1" indent="-285750" algn="l">
-              <a:buFont typeface="Courier New" panose="02070309020205020404" pitchFamily="49" charset="0"/>
-              <a:buChar char="o"/>
-            </a:pPr>
-            <a:r>
-              <a:rPr lang="en-US" b="1" i="0" dirty="0">
-                <a:solidFill>
-                  <a:srgbClr val="000000"/>
-                </a:solidFill>
-                <a:effectLst/>
-                <a:latin typeface="Calibri" panose="020F0502020204030204" pitchFamily="34" charset="0"/>
-              </a:rPr>
-              <a:t>Unit testing and CI</a:t>
-            </a:r>
-          </a:p>
-        </p:txBody>
-      </p:sp>
-    </p:spTree>
-    <p:extLst>
-      <p:ext uri="{BB962C8B-B14F-4D97-AF65-F5344CB8AC3E}">
-        <p14:creationId xmlns:p14="http://schemas.microsoft.com/office/powerpoint/2010/main" val="1935174185"/>
       </p:ext>
     </p:extLst>
   </p:cSld>
@@ -16005,415 +15888,814 @@
           <a:lstStyle/>
           <a:p>
             <a:r>
-              <a:rPr lang="en-US" sz="3600" cap="small" dirty="0"/>
-              <a:t>Private Side </a:t>
-            </a:r>
-            <a:r>
               <a:rPr lang="en-US" sz="3600" dirty="0"/>
-              <a:t>– UPDATES</a:t>
-            </a:r>
-          </a:p>
-        </p:txBody>
-      </p:sp>
-      <p:sp>
-        <p:nvSpPr>
-          <p:cNvPr id="3" name="TextBox 2">
-            <a:extLst>
-              <a:ext uri="{FF2B5EF4-FFF2-40B4-BE49-F238E27FC236}">
-                <a16:creationId xmlns:a16="http://schemas.microsoft.com/office/drawing/2014/main" id="{585FE47C-A4FF-D018-2E69-4649505A0101}"/>
-              </a:ext>
-            </a:extLst>
-          </p:cNvPr>
-          <p:cNvSpPr txBox="1"/>
+              <a:t>OPEN POINTS (ESA)</a:t>
+            </a:r>
+          </a:p>
+        </p:txBody>
+      </p:sp>
+      <p:sp>
+        <p:nvSpPr>
+          <p:cNvPr id="3" name="Title 1">
+            <a:extLst>
+              <a:ext uri="{FF2B5EF4-FFF2-40B4-BE49-F238E27FC236}">
+                <a16:creationId xmlns:a16="http://schemas.microsoft.com/office/drawing/2014/main" id="{B52E019A-123B-AF6D-4564-51E402891A7D}"/>
+              </a:ext>
+            </a:extLst>
+          </p:cNvPr>
+          <p:cNvSpPr txBox="1">
+            <a:spLocks/>
+          </p:cNvSpPr>
           <p:nvPr/>
         </p:nvSpPr>
         <p:spPr>
           <a:xfrm>
-            <a:off x="989040" y="2662599"/>
-            <a:ext cx="10795519" cy="1200329"/>
+            <a:off x="838200" y="2940910"/>
+            <a:ext cx="10515600" cy="605259"/>
           </a:xfrm>
           <a:prstGeom prst="rect">
             <a:avLst/>
           </a:prstGeom>
-          <a:noFill/>
-        </p:spPr>
-        <p:txBody>
-          <a:bodyPr wrap="square" rtlCol="0">
-            <a:spAutoFit/>
+        </p:spPr>
+        <p:txBody>
+          <a:bodyPr vert="horz" lIns="91440" tIns="45720" rIns="91440" bIns="45720" rtlCol="0" anchor="ctr">
+            <a:noAutofit/>
           </a:bodyPr>
-          <a:lstStyle/>
-          <a:p>
-            <a:r>
-              <a:rPr lang="en-US" b="1" cap="small" dirty="0" err="1"/>
-              <a:t>Arepyextras</a:t>
-            </a:r>
-            <a:r>
-              <a:rPr lang="en-US" b="1" cap="small" dirty="0"/>
-              <a:t> Quality</a:t>
-            </a:r>
-          </a:p>
-          <a:p>
-            <a:pPr marL="285750" indent="-285750">
-              <a:buFont typeface="Arial" panose="020B0604020202020204" pitchFamily="34" charset="0"/>
-              <a:buChar char="•"/>
-            </a:pPr>
-            <a:r>
-              <a:rPr lang="en-US" dirty="0"/>
-              <a:t>NESZ analysis implementation							</a:t>
-            </a:r>
-            <a:r>
-              <a:rPr lang="en-US" dirty="0">
+          <a:lstStyle>
+            <a:lvl1pPr algn="l" defTabSz="914400" rtl="0" eaLnBrk="1" latinLnBrk="0" hangingPunct="1">
+              <a:lnSpc>
+                <a:spcPct val="90000"/>
+              </a:lnSpc>
+              <a:spcBef>
+                <a:spcPct val="0"/>
+              </a:spcBef>
+              <a:buNone/>
+              <a:defRPr sz="4400" kern="1200">
                 <a:solidFill>
-                  <a:srgbClr val="0070C0"/>
+                  <a:schemeClr val="tx1"/>
                 </a:solidFill>
-              </a:rPr>
-              <a:t>[ONGOING]</a:t>
-            </a:r>
-            <a:endParaRPr lang="en-US" dirty="0">
-              <a:solidFill>
-                <a:srgbClr val="00B050"/>
-              </a:solidFill>
-            </a:endParaRPr>
-          </a:p>
-          <a:p>
-            <a:pPr marL="285750" indent="-285750">
-              <a:buFont typeface="Arial" panose="020B0604020202020204" pitchFamily="34" charset="0"/>
-              <a:buChar char="•"/>
-            </a:pPr>
-            <a:r>
-              <a:rPr lang="en-US" dirty="0"/>
-              <a:t>gamma profiles analysis implementation (RAIN FOREST?)</a:t>
-            </a:r>
-            <a:r>
-              <a:rPr lang="en-US" dirty="0">
-                <a:solidFill>
-                  <a:srgbClr val="C00000"/>
-                </a:solidFill>
-              </a:rPr>
-              <a:t>			</a:t>
-            </a:r>
-            <a:r>
-              <a:rPr lang="en-US" dirty="0">
-                <a:solidFill>
-                  <a:srgbClr val="0070C0"/>
-                </a:solidFill>
-              </a:rPr>
-              <a:t>[ONGOING]</a:t>
-            </a:r>
-          </a:p>
-          <a:p>
-            <a:pPr marL="285750" indent="-285750">
-              <a:buFont typeface="Arial" panose="020B0604020202020204" pitchFamily="34" charset="0"/>
-              <a:buChar char="•"/>
-            </a:pPr>
-            <a:r>
-              <a:rPr lang="en-US" dirty="0"/>
-              <a:t>additional output quantities to match the needs of post-processing</a:t>
-            </a:r>
-            <a:r>
-              <a:rPr lang="en-US" dirty="0">
-                <a:solidFill>
-                  <a:srgbClr val="0070C0"/>
-                </a:solidFill>
-              </a:rPr>
-              <a:t>		[ONGOING]</a:t>
-            </a:r>
-            <a:endParaRPr lang="en-US" dirty="0">
-              <a:solidFill>
-                <a:srgbClr val="C00000"/>
-              </a:solidFill>
-            </a:endParaRPr>
-          </a:p>
-        </p:txBody>
-      </p:sp>
-      <p:sp>
-        <p:nvSpPr>
-          <p:cNvPr id="9" name="TextBox 8">
-            <a:extLst>
-              <a:ext uri="{FF2B5EF4-FFF2-40B4-BE49-F238E27FC236}">
-                <a16:creationId xmlns:a16="http://schemas.microsoft.com/office/drawing/2014/main" id="{DB88366A-867E-0FC6-09B2-2DF8BB3E76E9}"/>
-              </a:ext>
-            </a:extLst>
-          </p:cNvPr>
-          <p:cNvSpPr txBox="1"/>
-          <p:nvPr/>
-        </p:nvSpPr>
-        <p:spPr>
-          <a:xfrm>
-            <a:off x="989040" y="4084183"/>
-            <a:ext cx="10795519" cy="2308324"/>
-          </a:xfrm>
-          <a:prstGeom prst="rect">
-            <a:avLst/>
-          </a:prstGeom>
-          <a:noFill/>
-        </p:spPr>
-        <p:txBody>
-          <a:bodyPr wrap="square" rtlCol="0">
-            <a:spAutoFit/>
-          </a:bodyPr>
-          <a:lstStyle/>
-          <a:p>
-            <a:r>
-              <a:rPr lang="en-US" b="1" cap="small" dirty="0"/>
-              <a:t>SCT</a:t>
-            </a:r>
-          </a:p>
-          <a:p>
-            <a:pPr marL="285750" indent="-285750">
-              <a:buFont typeface="Arial" panose="020B0604020202020204" pitchFamily="34" charset="0"/>
-              <a:buChar char="•"/>
-            </a:pPr>
-            <a:r>
-              <a:rPr lang="en-US" dirty="0"/>
-              <a:t>define operation flow and configurability (accessible tunable parameters)	</a:t>
-            </a:r>
-            <a:r>
-              <a:rPr lang="en-US" dirty="0">
-                <a:solidFill>
-                  <a:srgbClr val="0070C0"/>
-                </a:solidFill>
-              </a:rPr>
-              <a:t>	</a:t>
-            </a:r>
-            <a:r>
-              <a:rPr lang="en-US" dirty="0">
-                <a:solidFill>
-                  <a:srgbClr val="FFC000"/>
-                </a:solidFill>
-              </a:rPr>
-              <a:t>[~DONE]</a:t>
-            </a:r>
-          </a:p>
-          <a:p>
-            <a:pPr marL="285750" indent="-285750">
-              <a:buFont typeface="Arial" panose="020B0604020202020204" pitchFamily="34" charset="0"/>
-              <a:buChar char="•"/>
-            </a:pPr>
-            <a:r>
-              <a:rPr lang="en-US" dirty="0"/>
-              <a:t>time corrections module (specific for sentinel-1) implementation	</a:t>
-            </a:r>
-            <a:r>
-              <a:rPr lang="en-US" dirty="0">
-                <a:solidFill>
-                  <a:srgbClr val="C00000"/>
-                </a:solidFill>
-              </a:rPr>
-              <a:t>		</a:t>
-            </a:r>
-            <a:r>
-              <a:rPr lang="en-US" dirty="0">
-                <a:solidFill>
-                  <a:srgbClr val="FFC000"/>
-                </a:solidFill>
-              </a:rPr>
-              <a:t>[~DONE]</a:t>
-            </a:r>
-          </a:p>
-          <a:p>
-            <a:pPr marL="285750" indent="-285750">
-              <a:buFont typeface="Arial" panose="020B0604020202020204" pitchFamily="34" charset="0"/>
-              <a:buChar char="•"/>
-            </a:pPr>
-            <a:r>
-              <a:rPr lang="en-US" dirty="0"/>
-              <a:t>documentation</a:t>
-            </a:r>
-            <a:r>
-              <a:rPr lang="en-US" dirty="0">
-                <a:solidFill>
-                  <a:srgbClr val="FFC000"/>
-                </a:solidFill>
-              </a:rPr>
-              <a:t>								</a:t>
-            </a:r>
-            <a:r>
-              <a:rPr lang="en-US" dirty="0">
-                <a:solidFill>
-                  <a:srgbClr val="0070C0"/>
-                </a:solidFill>
-              </a:rPr>
-              <a:t>[ONGOING]</a:t>
-            </a:r>
-            <a:endParaRPr lang="en-US" dirty="0">
-              <a:solidFill>
-                <a:srgbClr val="FFC000"/>
-              </a:solidFill>
-            </a:endParaRPr>
-          </a:p>
-          <a:p>
-            <a:pPr marL="285750" indent="-285750">
-              <a:buFont typeface="Arial" panose="020B0604020202020204" pitchFamily="34" charset="0"/>
-              <a:buChar char="•"/>
-            </a:pPr>
-            <a:r>
-              <a:rPr lang="en-US" dirty="0"/>
-              <a:t>define Operation Modes for the CLI tool						</a:t>
-            </a:r>
-            <a:r>
-              <a:rPr lang="en-US" dirty="0">
-                <a:solidFill>
-                  <a:srgbClr val="C00000"/>
-                </a:solidFill>
-              </a:rPr>
-              <a:t>[TBD]</a:t>
-            </a:r>
-            <a:endParaRPr lang="en-US" dirty="0">
-              <a:solidFill>
-                <a:srgbClr val="0070C0"/>
-              </a:solidFill>
-            </a:endParaRPr>
-          </a:p>
-          <a:p>
-            <a:pPr marL="285750" indent="-285750">
-              <a:buFont typeface="Arial" panose="020B0604020202020204" pitchFamily="34" charset="0"/>
-              <a:buChar char="•"/>
-            </a:pPr>
-            <a:r>
-              <a:rPr lang="en-US" dirty="0"/>
-              <a:t>introduction of new products (ETAD and MPC)</a:t>
-            </a:r>
-            <a:r>
-              <a:rPr lang="en-US" dirty="0">
-                <a:solidFill>
-                  <a:srgbClr val="C00000"/>
-                </a:solidFill>
-              </a:rPr>
-              <a:t>					[TBD]</a:t>
-            </a:r>
-          </a:p>
-          <a:p>
-            <a:pPr marL="285750" indent="-285750">
-              <a:buFont typeface="Arial" panose="020B0604020202020204" pitchFamily="34" charset="0"/>
-              <a:buChar char="•"/>
-            </a:pPr>
-            <a:r>
-              <a:rPr lang="en-US" dirty="0"/>
-              <a:t>calibration sites gathering and database population + rethinking?</a:t>
-            </a:r>
-            <a:r>
-              <a:rPr lang="en-US" dirty="0">
-                <a:solidFill>
-                  <a:srgbClr val="00B050"/>
-                </a:solidFill>
-              </a:rPr>
-              <a:t>			</a:t>
-            </a:r>
-            <a:r>
-              <a:rPr lang="en-US" dirty="0">
-                <a:solidFill>
-                  <a:srgbClr val="002060"/>
-                </a:solidFill>
-              </a:rPr>
-              <a:t>[ON-HOLD]</a:t>
-            </a:r>
-          </a:p>
-          <a:p>
-            <a:pPr marL="285750" indent="-285750">
-              <a:buFont typeface="Arial" panose="020B0604020202020204" pitchFamily="34" charset="0"/>
-              <a:buChar char="•"/>
-            </a:pPr>
-            <a:r>
-              <a:rPr lang="en-US" dirty="0"/>
-              <a:t>interferometry analysis</a:t>
-            </a:r>
-            <a:r>
-              <a:rPr lang="en-US" dirty="0">
-                <a:solidFill>
-                  <a:srgbClr val="C00000"/>
-                </a:solidFill>
-              </a:rPr>
-              <a:t>							[?]</a:t>
-            </a:r>
-          </a:p>
-        </p:txBody>
-      </p:sp>
-      <p:sp>
-        <p:nvSpPr>
-          <p:cNvPr id="4" name="TextBox 3">
-            <a:extLst>
-              <a:ext uri="{FF2B5EF4-FFF2-40B4-BE49-F238E27FC236}">
-                <a16:creationId xmlns:a16="http://schemas.microsoft.com/office/drawing/2014/main" id="{3411D568-0E52-A5B3-A9D7-5930939B8919}"/>
-              </a:ext>
-            </a:extLst>
-          </p:cNvPr>
-          <p:cNvSpPr txBox="1"/>
-          <p:nvPr/>
-        </p:nvSpPr>
-        <p:spPr>
-          <a:xfrm>
-            <a:off x="989041" y="1372319"/>
-            <a:ext cx="10795519" cy="923330"/>
-          </a:xfrm>
-          <a:prstGeom prst="rect">
-            <a:avLst/>
-          </a:prstGeom>
-          <a:noFill/>
-          <a:ln w="38100">
-            <a:solidFill>
-              <a:srgbClr val="FF0000"/>
-            </a:solidFill>
-          </a:ln>
-        </p:spPr>
-        <p:txBody>
-          <a:bodyPr wrap="square" rtlCol="0">
-            <a:spAutoFit/>
-          </a:bodyPr>
-          <a:lstStyle/>
-          <a:p>
-            <a:r>
-              <a:rPr lang="en-US" b="1" cap="small" dirty="0"/>
-              <a:t>MILESTONE 1/2</a:t>
-            </a:r>
-          </a:p>
-          <a:p>
-            <a:pPr marL="285750" indent="-285750">
-              <a:buFont typeface="Arial" panose="020B0604020202020204" pitchFamily="34" charset="0"/>
-              <a:buChar char="•"/>
-            </a:pPr>
-            <a:r>
-              <a:rPr lang="en-US" dirty="0"/>
-              <a:t>SLC complete Point Target Analysis and benchmarking with old SCT		</a:t>
-            </a:r>
-            <a:r>
-              <a:rPr lang="en-US" dirty="0">
-                <a:solidFill>
-                  <a:srgbClr val="00B050"/>
-                </a:solidFill>
-              </a:rPr>
-              <a:t>[DONE]</a:t>
-            </a:r>
-          </a:p>
-          <a:p>
-            <a:pPr marL="285750" indent="-285750">
-              <a:buFont typeface="Arial" panose="020B0604020202020204" pitchFamily="34" charset="0"/>
-              <a:buChar char="•"/>
-            </a:pPr>
-            <a:r>
-              <a:rPr lang="en-US" dirty="0"/>
-              <a:t>GRD complete Point Target Analysis and benchmarking with old SCT		</a:t>
-            </a:r>
-            <a:r>
-              <a:rPr lang="en-US" dirty="0">
-                <a:solidFill>
-                  <a:srgbClr val="0070C0"/>
-                </a:solidFill>
-              </a:rPr>
-              <a:t>[ONGOING]</a:t>
-            </a:r>
-            <a:endParaRPr lang="en-US" dirty="0">
-              <a:solidFill>
-                <a:srgbClr val="00B050"/>
-              </a:solidFill>
-            </a:endParaRPr>
-          </a:p>
-        </p:txBody>
-      </p:sp>
+                <a:latin typeface="+mj-lt"/>
+                <a:ea typeface="+mj-ea"/>
+                <a:cs typeface="+mj-cs"/>
+              </a:defRPr>
+            </a:lvl1pPr>
+          </a:lstStyle>
+          <a:p>
+            <a:r>
+              <a:rPr lang="en-US" sz="3600" dirty="0"/>
+              <a:t>OPEN POINTS (Internal)</a:t>
+            </a:r>
+          </a:p>
+        </p:txBody>
+      </p:sp>
+      <p:graphicFrame>
+        <p:nvGraphicFramePr>
+          <p:cNvPr id="6" name="Table 5">
+            <a:extLst>
+              <a:ext uri="{FF2B5EF4-FFF2-40B4-BE49-F238E27FC236}">
+                <a16:creationId xmlns:a16="http://schemas.microsoft.com/office/drawing/2014/main" id="{53997F64-401B-1EBC-3535-A6533B1E4349}"/>
+              </a:ext>
+            </a:extLst>
+          </p:cNvPr>
+          <p:cNvGraphicFramePr>
+            <a:graphicFrameLocks noGrp="1"/>
+          </p:cNvGraphicFramePr>
+          <p:nvPr>
+            <p:extLst>
+              <p:ext uri="{D42A27DB-BD31-4B8C-83A1-F6EECF244321}">
+                <p14:modId xmlns:p14="http://schemas.microsoft.com/office/powerpoint/2010/main" val="3019676654"/>
+              </p:ext>
+            </p:extLst>
+          </p:nvPr>
+        </p:nvGraphicFramePr>
+        <p:xfrm>
+          <a:off x="1120563" y="970384"/>
+          <a:ext cx="9670932" cy="1833880"/>
+        </p:xfrm>
+        <a:graphic>
+          <a:graphicData uri="http://schemas.openxmlformats.org/drawingml/2006/table">
+            <a:tbl>
+              <a:tblPr firstRow="1" bandRow="1">
+                <a:tableStyleId>{5C22544A-7EE6-4342-B048-85BDC9FD1C3A}</a:tableStyleId>
+              </a:tblPr>
+              <a:tblGrid>
+                <a:gridCol w="3223644">
+                  <a:extLst>
+                    <a:ext uri="{9D8B030D-6E8A-4147-A177-3AD203B41FA5}">
+                      <a16:colId xmlns:a16="http://schemas.microsoft.com/office/drawing/2014/main" val="2788006904"/>
+                    </a:ext>
+                  </a:extLst>
+                </a:gridCol>
+                <a:gridCol w="3223644">
+                  <a:extLst>
+                    <a:ext uri="{9D8B030D-6E8A-4147-A177-3AD203B41FA5}">
+                      <a16:colId xmlns:a16="http://schemas.microsoft.com/office/drawing/2014/main" val="4063229635"/>
+                    </a:ext>
+                  </a:extLst>
+                </a:gridCol>
+                <a:gridCol w="3223644">
+                  <a:extLst>
+                    <a:ext uri="{9D8B030D-6E8A-4147-A177-3AD203B41FA5}">
+                      <a16:colId xmlns:a16="http://schemas.microsoft.com/office/drawing/2014/main" val="4073128311"/>
+                    </a:ext>
+                  </a:extLst>
+                </a:gridCol>
+              </a:tblGrid>
+              <a:tr h="370840">
+                <a:tc>
+                  <a:txBody>
+                    <a:bodyPr/>
+                    <a:lstStyle/>
+                    <a:p>
+                      <a:pPr algn="ctr"/>
+                      <a:r>
+                        <a:rPr lang="en-US" dirty="0"/>
+                        <a:t>Issue</a:t>
+                      </a:r>
+                    </a:p>
+                  </a:txBody>
+                  <a:tcPr/>
+                </a:tc>
+                <a:tc>
+                  <a:txBody>
+                    <a:bodyPr/>
+                    <a:lstStyle/>
+                    <a:p>
+                      <a:pPr algn="ctr"/>
+                      <a:r>
+                        <a:rPr lang="en-US" dirty="0"/>
+                        <a:t>Possible Solutions</a:t>
+                      </a:r>
+                    </a:p>
+                  </a:txBody>
+                  <a:tcPr/>
+                </a:tc>
+                <a:tc>
+                  <a:txBody>
+                    <a:bodyPr/>
+                    <a:lstStyle/>
+                    <a:p>
+                      <a:pPr algn="ctr"/>
+                      <a:r>
+                        <a:rPr lang="en-US" dirty="0"/>
+                        <a:t>Status</a:t>
+                      </a:r>
+                    </a:p>
+                  </a:txBody>
+                  <a:tcPr/>
+                </a:tc>
+                <a:extLst>
+                  <a:ext uri="{0D108BD9-81ED-4DB2-BD59-A6C34878D82A}">
+                    <a16:rowId xmlns:a16="http://schemas.microsoft.com/office/drawing/2014/main" val="4035181936"/>
+                  </a:ext>
+                </a:extLst>
+              </a:tr>
+              <a:tr h="370840">
+                <a:tc>
+                  <a:txBody>
+                    <a:bodyPr/>
+                    <a:lstStyle/>
+                    <a:p>
+                      <a:pPr marL="0" marR="0" lvl="0" indent="0" algn="l" defTabSz="914400" rtl="0" eaLnBrk="1" fontAlgn="auto" latinLnBrk="0" hangingPunct="1">
+                        <a:lnSpc>
+                          <a:spcPct val="100000"/>
+                        </a:lnSpc>
+                        <a:spcBef>
+                          <a:spcPts val="0"/>
+                        </a:spcBef>
+                        <a:spcAft>
+                          <a:spcPts val="0"/>
+                        </a:spcAft>
+                        <a:buClrTx/>
+                        <a:buSzTx/>
+                        <a:buFontTx/>
+                        <a:buNone/>
+                        <a:tabLst/>
+                        <a:defRPr/>
+                      </a:pPr>
+                      <a:r>
+                        <a:rPr lang="en-US" sz="1400" b="1" dirty="0">
+                          <a:solidFill>
+                            <a:srgbClr val="000000"/>
+                          </a:solidFill>
+                          <a:latin typeface="Calibri" panose="020F0502020204030204" pitchFamily="34" charset="0"/>
+                        </a:rPr>
+                        <a:t>Change IERS Solid Tides Fortran code management (deploy issue)</a:t>
+                      </a:r>
+                    </a:p>
+                    <a:p>
+                      <a:pPr algn="l"/>
+                      <a:endParaRPr lang="en-US" sz="1400" dirty="0"/>
+                    </a:p>
+                  </a:txBody>
+                  <a:tcPr/>
+                </a:tc>
+                <a:tc>
+                  <a:txBody>
+                    <a:bodyPr/>
+                    <a:lstStyle/>
+                    <a:p>
+                      <a:pPr algn="l"/>
+                      <a:r>
+                        <a:rPr lang="en-US" sz="1400" dirty="0"/>
+                        <a:t>- </a:t>
+                      </a:r>
+                      <a:r>
+                        <a:rPr lang="en-US" sz="1400" dirty="0" err="1"/>
+                        <a:t>build_ci_tools</a:t>
+                      </a:r>
+                      <a:r>
+                        <a:rPr lang="en-US" sz="1400" dirty="0"/>
+                        <a:t>: multiple wheels platform dependent</a:t>
+                      </a:r>
+                    </a:p>
+                    <a:p>
+                      <a:pPr algn="l"/>
+                      <a:r>
+                        <a:rPr lang="en-US" sz="1400" dirty="0"/>
+                        <a:t>- wheel compiled on target machine</a:t>
+                      </a:r>
+                    </a:p>
+                    <a:p>
+                      <a:pPr algn="l"/>
+                      <a:r>
+                        <a:rPr lang="en-US" sz="1400" dirty="0"/>
+                        <a:t>- microservice?</a:t>
+                      </a:r>
+                    </a:p>
+                  </a:txBody>
+                  <a:tcPr/>
+                </a:tc>
+                <a:tc>
+                  <a:txBody>
+                    <a:bodyPr/>
+                    <a:lstStyle/>
+                    <a:p>
+                      <a:pPr algn="ctr"/>
+                      <a:r>
+                        <a:rPr lang="en-US" sz="1400" dirty="0"/>
+                        <a:t>TBD</a:t>
+                      </a:r>
+                    </a:p>
+                  </a:txBody>
+                  <a:tcPr/>
+                </a:tc>
+                <a:extLst>
+                  <a:ext uri="{0D108BD9-81ED-4DB2-BD59-A6C34878D82A}">
+                    <a16:rowId xmlns:a16="http://schemas.microsoft.com/office/drawing/2014/main" val="3695501939"/>
+                  </a:ext>
+                </a:extLst>
+              </a:tr>
+              <a:tr h="370840">
+                <a:tc>
+                  <a:txBody>
+                    <a:bodyPr/>
+                    <a:lstStyle/>
+                    <a:p>
+                      <a:pPr marL="0" marR="0" lvl="0" indent="0" algn="l" defTabSz="914400" rtl="0" eaLnBrk="1" fontAlgn="auto" latinLnBrk="0" hangingPunct="1">
+                        <a:lnSpc>
+                          <a:spcPct val="100000"/>
+                        </a:lnSpc>
+                        <a:spcBef>
+                          <a:spcPts val="0"/>
+                        </a:spcBef>
+                        <a:spcAft>
+                          <a:spcPts val="0"/>
+                        </a:spcAft>
+                        <a:buClrTx/>
+                        <a:buSzTx/>
+                        <a:buFontTx/>
+                        <a:buNone/>
+                        <a:tabLst/>
+                        <a:defRPr/>
+                      </a:pPr>
+                      <a:r>
+                        <a:rPr lang="en-US" sz="1400" b="1" dirty="0">
+                          <a:solidFill>
+                            <a:srgbClr val="000000"/>
+                          </a:solidFill>
+                          <a:latin typeface="Calibri" panose="020F0502020204030204" pitchFamily="34" charset="0"/>
+                        </a:rPr>
+                        <a:t>Add configuration settings to output</a:t>
+                      </a:r>
+                    </a:p>
+                  </a:txBody>
+                  <a:tcPr/>
+                </a:tc>
+                <a:tc>
+                  <a:txBody>
+                    <a:bodyPr/>
+                    <a:lstStyle/>
+                    <a:p>
+                      <a:pPr algn="l"/>
+                      <a:r>
+                        <a:rPr lang="en-US" sz="1400" dirty="0"/>
+                        <a:t>Save same input configuration to output folder</a:t>
+                      </a:r>
+                    </a:p>
+                  </a:txBody>
+                  <a:tcPr/>
+                </a:tc>
+                <a:tc>
+                  <a:txBody>
+                    <a:bodyPr/>
+                    <a:lstStyle/>
+                    <a:p>
+                      <a:pPr algn="ctr"/>
+                      <a:r>
+                        <a:rPr lang="en-US" sz="1400" dirty="0"/>
+                        <a:t>TBD</a:t>
+                      </a:r>
+                    </a:p>
+                  </a:txBody>
+                  <a:tcPr/>
+                </a:tc>
+                <a:extLst>
+                  <a:ext uri="{0D108BD9-81ED-4DB2-BD59-A6C34878D82A}">
+                    <a16:rowId xmlns:a16="http://schemas.microsoft.com/office/drawing/2014/main" val="201546513"/>
+                  </a:ext>
+                </a:extLst>
+              </a:tr>
+            </a:tbl>
+          </a:graphicData>
+        </a:graphic>
+      </p:graphicFrame>
+      <p:graphicFrame>
+        <p:nvGraphicFramePr>
+          <p:cNvPr id="7" name="Table 6">
+            <a:extLst>
+              <a:ext uri="{FF2B5EF4-FFF2-40B4-BE49-F238E27FC236}">
+                <a16:creationId xmlns:a16="http://schemas.microsoft.com/office/drawing/2014/main" id="{C4D2F76D-E5F4-A42C-83C3-277B7EFBB7D9}"/>
+              </a:ext>
+            </a:extLst>
+          </p:cNvPr>
+          <p:cNvGraphicFramePr>
+            <a:graphicFrameLocks noGrp="1"/>
+          </p:cNvGraphicFramePr>
+          <p:nvPr>
+            <p:extLst>
+              <p:ext uri="{D42A27DB-BD31-4B8C-83A1-F6EECF244321}">
+                <p14:modId xmlns:p14="http://schemas.microsoft.com/office/powerpoint/2010/main" val="2334445901"/>
+              </p:ext>
+            </p:extLst>
+          </p:nvPr>
+        </p:nvGraphicFramePr>
+        <p:xfrm>
+          <a:off x="1120563" y="3612515"/>
+          <a:ext cx="9670932" cy="2880360"/>
+        </p:xfrm>
+        <a:graphic>
+          <a:graphicData uri="http://schemas.openxmlformats.org/drawingml/2006/table">
+            <a:tbl>
+              <a:tblPr firstRow="1" bandRow="1">
+                <a:tableStyleId>{00A15C55-8517-42AA-B614-E9B94910E393}</a:tableStyleId>
+              </a:tblPr>
+              <a:tblGrid>
+                <a:gridCol w="3223644">
+                  <a:extLst>
+                    <a:ext uri="{9D8B030D-6E8A-4147-A177-3AD203B41FA5}">
+                      <a16:colId xmlns:a16="http://schemas.microsoft.com/office/drawing/2014/main" val="2788006904"/>
+                    </a:ext>
+                  </a:extLst>
+                </a:gridCol>
+                <a:gridCol w="3223644">
+                  <a:extLst>
+                    <a:ext uri="{9D8B030D-6E8A-4147-A177-3AD203B41FA5}">
+                      <a16:colId xmlns:a16="http://schemas.microsoft.com/office/drawing/2014/main" val="4063229635"/>
+                    </a:ext>
+                  </a:extLst>
+                </a:gridCol>
+                <a:gridCol w="3223644">
+                  <a:extLst>
+                    <a:ext uri="{9D8B030D-6E8A-4147-A177-3AD203B41FA5}">
+                      <a16:colId xmlns:a16="http://schemas.microsoft.com/office/drawing/2014/main" val="4073128311"/>
+                    </a:ext>
+                  </a:extLst>
+                </a:gridCol>
+              </a:tblGrid>
+              <a:tr h="370840">
+                <a:tc>
+                  <a:txBody>
+                    <a:bodyPr/>
+                    <a:lstStyle/>
+                    <a:p>
+                      <a:pPr algn="ctr"/>
+                      <a:r>
+                        <a:rPr lang="en-US" dirty="0"/>
+                        <a:t>Issue</a:t>
+                      </a:r>
+                    </a:p>
+                  </a:txBody>
+                  <a:tcPr/>
+                </a:tc>
+                <a:tc>
+                  <a:txBody>
+                    <a:bodyPr/>
+                    <a:lstStyle/>
+                    <a:p>
+                      <a:pPr algn="ctr"/>
+                      <a:r>
+                        <a:rPr lang="en-US" dirty="0"/>
+                        <a:t>Possible Solutions</a:t>
+                      </a:r>
+                    </a:p>
+                  </a:txBody>
+                  <a:tcPr/>
+                </a:tc>
+                <a:tc>
+                  <a:txBody>
+                    <a:bodyPr/>
+                    <a:lstStyle/>
+                    <a:p>
+                      <a:pPr algn="ctr"/>
+                      <a:r>
+                        <a:rPr lang="en-US" dirty="0"/>
+                        <a:t>Status</a:t>
+                      </a:r>
+                    </a:p>
+                  </a:txBody>
+                  <a:tcPr/>
+                </a:tc>
+                <a:extLst>
+                  <a:ext uri="{0D108BD9-81ED-4DB2-BD59-A6C34878D82A}">
+                    <a16:rowId xmlns:a16="http://schemas.microsoft.com/office/drawing/2014/main" val="4035181936"/>
+                  </a:ext>
+                </a:extLst>
+              </a:tr>
+              <a:tr h="370840">
+                <a:tc>
+                  <a:txBody>
+                    <a:bodyPr/>
+                    <a:lstStyle/>
+                    <a:p>
+                      <a:pPr marL="0" marR="0" lvl="0" indent="0" algn="l" defTabSz="914400" rtl="0" eaLnBrk="1" fontAlgn="auto" latinLnBrk="0" hangingPunct="1">
+                        <a:lnSpc>
+                          <a:spcPct val="100000"/>
+                        </a:lnSpc>
+                        <a:spcBef>
+                          <a:spcPts val="0"/>
+                        </a:spcBef>
+                        <a:spcAft>
+                          <a:spcPts val="0"/>
+                        </a:spcAft>
+                        <a:buClrTx/>
+                        <a:buSzTx/>
+                        <a:buFontTx/>
+                        <a:buNone/>
+                        <a:tabLst/>
+                        <a:defRPr/>
+                      </a:pPr>
+                      <a:r>
+                        <a:rPr lang="en-US" sz="1400" b="1" dirty="0">
+                          <a:solidFill>
+                            <a:srgbClr val="000000"/>
+                          </a:solidFill>
+                        </a:rPr>
+                        <a:t>Internal Docker for analysis</a:t>
+                      </a:r>
+                    </a:p>
+                  </a:txBody>
+                  <a:tcPr/>
+                </a:tc>
+                <a:tc>
+                  <a:txBody>
+                    <a:bodyPr/>
+                    <a:lstStyle/>
+                    <a:p>
+                      <a:pPr algn="l"/>
+                      <a:r>
+                        <a:rPr lang="en-US" sz="1400" dirty="0"/>
+                        <a:t>Docker container with volume mounted from server where data persist?</a:t>
+                      </a:r>
+                    </a:p>
+                  </a:txBody>
+                  <a:tcPr/>
+                </a:tc>
+                <a:tc>
+                  <a:txBody>
+                    <a:bodyPr/>
+                    <a:lstStyle/>
+                    <a:p>
+                      <a:pPr algn="ctr"/>
+                      <a:r>
+                        <a:rPr lang="en-US" sz="1400" dirty="0"/>
+                        <a:t>TBD</a:t>
+                      </a:r>
+                    </a:p>
+                  </a:txBody>
+                  <a:tcPr/>
+                </a:tc>
+                <a:extLst>
+                  <a:ext uri="{0D108BD9-81ED-4DB2-BD59-A6C34878D82A}">
+                    <a16:rowId xmlns:a16="http://schemas.microsoft.com/office/drawing/2014/main" val="3695501939"/>
+                  </a:ext>
+                </a:extLst>
+              </a:tr>
+              <a:tr h="370840">
+                <a:tc>
+                  <a:txBody>
+                    <a:bodyPr/>
+                    <a:lstStyle/>
+                    <a:p>
+                      <a:pPr marL="0" marR="0" lvl="0" indent="0" algn="l" defTabSz="914400" rtl="0" eaLnBrk="1" fontAlgn="auto" latinLnBrk="0" hangingPunct="1">
+                        <a:lnSpc>
+                          <a:spcPct val="100000"/>
+                        </a:lnSpc>
+                        <a:spcBef>
+                          <a:spcPts val="0"/>
+                        </a:spcBef>
+                        <a:spcAft>
+                          <a:spcPts val="0"/>
+                        </a:spcAft>
+                        <a:buClrTx/>
+                        <a:buSzTx/>
+                        <a:buFontTx/>
+                        <a:buNone/>
+                        <a:tabLst/>
+                        <a:defRPr/>
+                      </a:pPr>
+                      <a:r>
+                        <a:rPr lang="en-US" sz="1400" b="1" dirty="0">
+                          <a:solidFill>
+                            <a:srgbClr val="000000"/>
+                          </a:solidFill>
+                        </a:rPr>
+                        <a:t>Integrate RCS Model</a:t>
+                      </a:r>
+                    </a:p>
+                  </a:txBody>
+                  <a:tcPr/>
+                </a:tc>
+                <a:tc>
+                  <a:txBody>
+                    <a:bodyPr/>
+                    <a:lstStyle/>
+                    <a:p>
+                      <a:pPr marL="0" marR="0" lvl="0" indent="0" algn="l" defTabSz="914400" rtl="0" eaLnBrk="1" fontAlgn="auto" latinLnBrk="0" hangingPunct="1">
+                        <a:lnSpc>
+                          <a:spcPct val="100000"/>
+                        </a:lnSpc>
+                        <a:spcBef>
+                          <a:spcPts val="0"/>
+                        </a:spcBef>
+                        <a:spcAft>
+                          <a:spcPts val="0"/>
+                        </a:spcAft>
+                        <a:buClrTx/>
+                        <a:buSzTx/>
+                        <a:buFontTx/>
+                        <a:buNone/>
+                        <a:tabLst/>
+                        <a:defRPr/>
+                      </a:pPr>
+                      <a:r>
+                        <a:rPr lang="en-US" sz="1400" dirty="0"/>
+                        <a:t>Integrate existing scripts?</a:t>
+                      </a:r>
+                    </a:p>
+                  </a:txBody>
+                  <a:tcPr/>
+                </a:tc>
+                <a:tc>
+                  <a:txBody>
+                    <a:bodyPr/>
+                    <a:lstStyle/>
+                    <a:p>
+                      <a:pPr algn="ctr"/>
+                      <a:r>
+                        <a:rPr lang="en-US" sz="1400" dirty="0"/>
+                        <a:t>TBD</a:t>
+                      </a:r>
+                    </a:p>
+                  </a:txBody>
+                  <a:tcPr/>
+                </a:tc>
+                <a:extLst>
+                  <a:ext uri="{0D108BD9-81ED-4DB2-BD59-A6C34878D82A}">
+                    <a16:rowId xmlns:a16="http://schemas.microsoft.com/office/drawing/2014/main" val="3402183586"/>
+                  </a:ext>
+                </a:extLst>
+              </a:tr>
+              <a:tr h="370840">
+                <a:tc>
+                  <a:txBody>
+                    <a:bodyPr/>
+                    <a:lstStyle/>
+                    <a:p>
+                      <a:pPr marL="0" marR="0" lvl="0" indent="0" algn="l" defTabSz="914400" rtl="0" eaLnBrk="1" fontAlgn="auto" latinLnBrk="0" hangingPunct="1">
+                        <a:lnSpc>
+                          <a:spcPct val="100000"/>
+                        </a:lnSpc>
+                        <a:spcBef>
+                          <a:spcPts val="0"/>
+                        </a:spcBef>
+                        <a:spcAft>
+                          <a:spcPts val="0"/>
+                        </a:spcAft>
+                        <a:buClrTx/>
+                        <a:buSzTx/>
+                        <a:buFontTx/>
+                        <a:buNone/>
+                        <a:tabLst/>
+                        <a:defRPr/>
+                      </a:pPr>
+                      <a:r>
+                        <a:rPr lang="en-US" sz="1400" b="1" dirty="0">
+                          <a:solidFill>
+                            <a:srgbClr val="000000"/>
+                          </a:solidFill>
+                          <a:latin typeface="Calibri" panose="020F0502020204030204" pitchFamily="34" charset="0"/>
+                        </a:rPr>
+                        <a:t>Interferometry: implement scripts (co-registration + coherency)</a:t>
+                      </a:r>
+                    </a:p>
+                  </a:txBody>
+                  <a:tcPr/>
+                </a:tc>
+                <a:tc>
+                  <a:txBody>
+                    <a:bodyPr/>
+                    <a:lstStyle/>
+                    <a:p>
+                      <a:pPr algn="l"/>
+                      <a:r>
+                        <a:rPr lang="en-US" sz="1400" dirty="0"/>
+                        <a:t>Integrate existing scripts</a:t>
+                      </a:r>
+                      <a:r>
+                        <a:rPr lang="en-US" sz="1200" dirty="0"/>
+                        <a:t>?</a:t>
+                      </a:r>
+                      <a:endParaRPr lang="en-US" sz="1400" dirty="0"/>
+                    </a:p>
+                  </a:txBody>
+                  <a:tcPr/>
+                </a:tc>
+                <a:tc>
+                  <a:txBody>
+                    <a:bodyPr/>
+                    <a:lstStyle/>
+                    <a:p>
+                      <a:pPr algn="ctr"/>
+                      <a:r>
+                        <a:rPr lang="en-US" sz="1400" dirty="0"/>
+                        <a:t>TBD</a:t>
+                      </a:r>
+                    </a:p>
+                  </a:txBody>
+                  <a:tcPr/>
+                </a:tc>
+                <a:extLst>
+                  <a:ext uri="{0D108BD9-81ED-4DB2-BD59-A6C34878D82A}">
+                    <a16:rowId xmlns:a16="http://schemas.microsoft.com/office/drawing/2014/main" val="201546513"/>
+                  </a:ext>
+                </a:extLst>
+              </a:tr>
+              <a:tr h="370840">
+                <a:tc>
+                  <a:txBody>
+                    <a:bodyPr/>
+                    <a:lstStyle/>
+                    <a:p>
+                      <a:pPr algn="l"/>
+                      <a:r>
+                        <a:rPr lang="en-US" sz="1400" b="1" kern="1200" dirty="0">
+                          <a:solidFill>
+                            <a:srgbClr val="000000"/>
+                          </a:solidFill>
+                          <a:latin typeface="Calibri" panose="020F0502020204030204" pitchFamily="34" charset="0"/>
+                          <a:ea typeface="+mn-ea"/>
+                          <a:cs typeface="+mn-cs"/>
+                        </a:rPr>
+                        <a:t>ETAD products</a:t>
+                      </a:r>
+                    </a:p>
+                  </a:txBody>
+                  <a:tcPr/>
+                </a:tc>
+                <a:tc>
+                  <a:txBody>
+                    <a:bodyPr/>
+                    <a:lstStyle/>
+                    <a:p>
+                      <a:pPr algn="l"/>
+                      <a:r>
+                        <a:rPr lang="en-US" sz="1400" dirty="0"/>
+                        <a:t>Develop support for </a:t>
+                      </a:r>
+                      <a:r>
+                        <a:rPr lang="en-US" sz="1400" dirty="0" err="1"/>
+                        <a:t>etad</a:t>
+                      </a:r>
+                      <a:r>
+                        <a:rPr lang="en-US" sz="1400" dirty="0"/>
+                        <a:t> products in </a:t>
+                      </a:r>
+                      <a:r>
+                        <a:rPr lang="en-US" sz="1400" dirty="0" err="1"/>
+                        <a:t>eo_products</a:t>
+                      </a:r>
+                      <a:r>
+                        <a:rPr lang="en-US" sz="1400" dirty="0"/>
+                        <a:t>?</a:t>
+                      </a:r>
+                    </a:p>
+                  </a:txBody>
+                  <a:tcPr/>
+                </a:tc>
+                <a:tc>
+                  <a:txBody>
+                    <a:bodyPr/>
+                    <a:lstStyle/>
+                    <a:p>
+                      <a:pPr algn="ctr"/>
+                      <a:r>
+                        <a:rPr lang="en-US" sz="1400" dirty="0">
+                          <a:solidFill>
+                            <a:srgbClr val="00B050"/>
+                          </a:solidFill>
+                        </a:rPr>
+                        <a:t>DONE</a:t>
+                      </a:r>
+                    </a:p>
+                  </a:txBody>
+                  <a:tcPr/>
+                </a:tc>
+                <a:extLst>
+                  <a:ext uri="{0D108BD9-81ED-4DB2-BD59-A6C34878D82A}">
+                    <a16:rowId xmlns:a16="http://schemas.microsoft.com/office/drawing/2014/main" val="249990251"/>
+                  </a:ext>
+                </a:extLst>
+              </a:tr>
+              <a:tr h="370840">
+                <a:tc>
+                  <a:txBody>
+                    <a:bodyPr/>
+                    <a:lstStyle/>
+                    <a:p>
+                      <a:pPr algn="l"/>
+                      <a:r>
+                        <a:rPr lang="en-US" sz="1400" b="1" kern="1200" dirty="0">
+                          <a:solidFill>
+                            <a:srgbClr val="000000"/>
+                          </a:solidFill>
+                          <a:latin typeface="Calibri" panose="020F0502020204030204" pitchFamily="34" charset="0"/>
+                          <a:ea typeface="+mn-ea"/>
+                          <a:cs typeface="+mn-cs"/>
+                        </a:rPr>
+                        <a:t>RISAT reader</a:t>
+                      </a:r>
+                    </a:p>
+                  </a:txBody>
+                  <a:tcPr/>
+                </a:tc>
+                <a:tc>
+                  <a:txBody>
+                    <a:bodyPr/>
+                    <a:lstStyle/>
+                    <a:p>
+                      <a:pPr algn="l"/>
+                      <a:r>
+                        <a:rPr lang="en-US" sz="1400" dirty="0"/>
+                        <a:t>Develop reader in </a:t>
+                      </a:r>
+                      <a:r>
+                        <a:rPr lang="en-US" sz="1400" dirty="0" err="1"/>
+                        <a:t>eo_products</a:t>
+                      </a:r>
+                      <a:endParaRPr lang="en-US" sz="1400" dirty="0"/>
+                    </a:p>
+                  </a:txBody>
+                  <a:tcPr/>
+                </a:tc>
+                <a:tc>
+                  <a:txBody>
+                    <a:bodyPr/>
+                    <a:lstStyle/>
+                    <a:p>
+                      <a:pPr algn="ctr"/>
+                      <a:r>
+                        <a:rPr lang="en-US" sz="1400" dirty="0"/>
+                        <a:t>TBD</a:t>
+                      </a:r>
+                    </a:p>
+                  </a:txBody>
+                  <a:tcPr/>
+                </a:tc>
+                <a:extLst>
+                  <a:ext uri="{0D108BD9-81ED-4DB2-BD59-A6C34878D82A}">
+                    <a16:rowId xmlns:a16="http://schemas.microsoft.com/office/drawing/2014/main" val="583849704"/>
+                  </a:ext>
+                </a:extLst>
+              </a:tr>
+            </a:tbl>
+          </a:graphicData>
+        </a:graphic>
+      </p:graphicFrame>
     </p:spTree>
     <p:extLst>
       <p:ext uri="{BB962C8B-B14F-4D97-AF65-F5344CB8AC3E}">
-        <p14:creationId xmlns:p14="http://schemas.microsoft.com/office/powerpoint/2010/main" val="1731143031"/>
+        <p14:creationId xmlns:p14="http://schemas.microsoft.com/office/powerpoint/2010/main" val="1935174185"/>
       </p:ext>
     </p:extLst>
   </p:cSld>
@@ -16474,7 +16756,7 @@
             </a:r>
             <a:r>
               <a:rPr lang="en-US" sz="3600" dirty="0"/>
-              <a:t>– COMPLETED TASKS 1/2</a:t>
+              <a:t>– UPDATES</a:t>
             </a:r>
           </a:p>
         </p:txBody>
@@ -16493,8 +16775,8 @@
         </p:nvSpPr>
         <p:spPr>
           <a:xfrm>
-            <a:off x="1026364" y="2446299"/>
-            <a:ext cx="10795519" cy="923330"/>
+            <a:off x="989039" y="2778435"/>
+            <a:ext cx="10795519" cy="369332"/>
           </a:xfrm>
           <a:prstGeom prst="rect">
             <a:avLst/>
@@ -16516,6 +16798,41 @@
               <a:t> Quality</a:t>
             </a:r>
           </a:p>
+        </p:txBody>
+      </p:sp>
+      <p:sp>
+        <p:nvSpPr>
+          <p:cNvPr id="9" name="TextBox 8">
+            <a:extLst>
+              <a:ext uri="{FF2B5EF4-FFF2-40B4-BE49-F238E27FC236}">
+                <a16:creationId xmlns:a16="http://schemas.microsoft.com/office/drawing/2014/main" id="{DB88366A-867E-0FC6-09B2-2DF8BB3E76E9}"/>
+              </a:ext>
+            </a:extLst>
+          </p:cNvPr>
+          <p:cNvSpPr txBox="1"/>
+          <p:nvPr/>
+        </p:nvSpPr>
+        <p:spPr>
+          <a:xfrm>
+            <a:off x="989039" y="4184551"/>
+            <a:ext cx="10795519" cy="1754326"/>
+          </a:xfrm>
+          <a:prstGeom prst="rect">
+            <a:avLst/>
+          </a:prstGeom>
+          <a:noFill/>
+        </p:spPr>
+        <p:txBody>
+          <a:bodyPr wrap="square" rtlCol="0">
+            <a:spAutoFit/>
+          </a:bodyPr>
+          <a:lstStyle/>
+          <a:p>
+            <a:r>
+              <a:rPr lang="en-US" b="1" cap="small" dirty="0"/>
+              <a:t>SCT</a:t>
+            </a:r>
+          </a:p>
           <a:p>
             <a:pPr marL="285750" indent="-285750">
               <a:buFont typeface="Arial" panose="020B0604020202020204" pitchFamily="34" charset="0"/>
@@ -16523,7 +16840,166 @@
             </a:pPr>
             <a:r>
               <a:rPr lang="en-US" dirty="0"/>
-              <a:t>refactoring to allow protocol-compliant input injection				</a:t>
+              <a:t>define operation flow and configurability (accessible tunable parameters)	</a:t>
+            </a:r>
+            <a:r>
+              <a:rPr lang="en-US" dirty="0">
+                <a:solidFill>
+                  <a:srgbClr val="0070C0"/>
+                </a:solidFill>
+              </a:rPr>
+              <a:t>	</a:t>
+            </a:r>
+            <a:r>
+              <a:rPr lang="en-US" dirty="0">
+                <a:solidFill>
+                  <a:srgbClr val="FFC000"/>
+                </a:solidFill>
+              </a:rPr>
+              <a:t>[~DONE]</a:t>
+            </a:r>
+          </a:p>
+          <a:p>
+            <a:pPr marL="285750" indent="-285750">
+              <a:buFont typeface="Arial" panose="020B0604020202020204" pitchFamily="34" charset="0"/>
+              <a:buChar char="•"/>
+            </a:pPr>
+            <a:r>
+              <a:rPr lang="en-US" dirty="0"/>
+              <a:t>documentation</a:t>
+            </a:r>
+            <a:r>
+              <a:rPr lang="en-US" dirty="0">
+                <a:solidFill>
+                  <a:srgbClr val="FFC000"/>
+                </a:solidFill>
+              </a:rPr>
+              <a:t>								</a:t>
+            </a:r>
+            <a:r>
+              <a:rPr lang="en-US" dirty="0">
+                <a:solidFill>
+                  <a:srgbClr val="0070C0"/>
+                </a:solidFill>
+              </a:rPr>
+              <a:t>[ONGOING]</a:t>
+            </a:r>
+            <a:endParaRPr lang="en-US" dirty="0">
+              <a:solidFill>
+                <a:srgbClr val="FFC000"/>
+              </a:solidFill>
+            </a:endParaRPr>
+          </a:p>
+          <a:p>
+            <a:pPr marL="285750" indent="-285750">
+              <a:buFont typeface="Arial" panose="020B0604020202020204" pitchFamily="34" charset="0"/>
+              <a:buChar char="•"/>
+            </a:pPr>
+            <a:r>
+              <a:rPr lang="en-US" dirty="0"/>
+              <a:t>introduction of new products (ETAD and MPC)</a:t>
+            </a:r>
+            <a:r>
+              <a:rPr lang="en-US" dirty="0">
+                <a:solidFill>
+                  <a:srgbClr val="C00000"/>
+                </a:solidFill>
+              </a:rPr>
+              <a:t>					[TBD]</a:t>
+            </a:r>
+          </a:p>
+          <a:p>
+            <a:pPr marL="285750" indent="-285750">
+              <a:buFont typeface="Arial" panose="020B0604020202020204" pitchFamily="34" charset="0"/>
+              <a:buChar char="•"/>
+            </a:pPr>
+            <a:r>
+              <a:rPr lang="en-US" dirty="0"/>
+              <a:t>calibration sites gathering and database population + rethinking?</a:t>
+            </a:r>
+            <a:r>
+              <a:rPr lang="en-US" dirty="0">
+                <a:solidFill>
+                  <a:srgbClr val="00B050"/>
+                </a:solidFill>
+              </a:rPr>
+              <a:t>			</a:t>
+            </a:r>
+            <a:r>
+              <a:rPr lang="en-US" dirty="0">
+                <a:solidFill>
+                  <a:srgbClr val="002060"/>
+                </a:solidFill>
+              </a:rPr>
+              <a:t>[ON-HOLD]</a:t>
+            </a:r>
+          </a:p>
+          <a:p>
+            <a:pPr marL="285750" indent="-285750">
+              <a:buFont typeface="Arial" panose="020B0604020202020204" pitchFamily="34" charset="0"/>
+              <a:buChar char="•"/>
+            </a:pPr>
+            <a:r>
+              <a:rPr lang="en-US" dirty="0"/>
+              <a:t>interferometry analysis</a:t>
+            </a:r>
+            <a:r>
+              <a:rPr lang="en-US" dirty="0">
+                <a:solidFill>
+                  <a:srgbClr val="C00000"/>
+                </a:solidFill>
+              </a:rPr>
+              <a:t>							[?]</a:t>
+            </a:r>
+          </a:p>
+        </p:txBody>
+      </p:sp>
+      <p:sp>
+        <p:nvSpPr>
+          <p:cNvPr id="4" name="TextBox 3">
+            <a:extLst>
+              <a:ext uri="{FF2B5EF4-FFF2-40B4-BE49-F238E27FC236}">
+                <a16:creationId xmlns:a16="http://schemas.microsoft.com/office/drawing/2014/main" id="{3411D568-0E52-A5B3-A9D7-5930939B8919}"/>
+              </a:ext>
+            </a:extLst>
+          </p:cNvPr>
+          <p:cNvSpPr txBox="1"/>
+          <p:nvPr/>
+        </p:nvSpPr>
+        <p:spPr>
+          <a:xfrm>
+            <a:off x="989041" y="1372319"/>
+            <a:ext cx="10795519" cy="923330"/>
+          </a:xfrm>
+          <a:prstGeom prst="rect">
+            <a:avLst/>
+          </a:prstGeom>
+          <a:noFill/>
+          <a:ln w="38100">
+            <a:solidFill>
+              <a:srgbClr val="FF0000"/>
+            </a:solidFill>
+          </a:ln>
+        </p:spPr>
+        <p:txBody>
+          <a:bodyPr wrap="square" rtlCol="0">
+            <a:spAutoFit/>
+          </a:bodyPr>
+          <a:lstStyle/>
+          <a:p>
+            <a:r>
+              <a:rPr lang="en-US" b="1" cap="small" dirty="0"/>
+              <a:t>MILESTONE 2/2</a:t>
+            </a:r>
+          </a:p>
+          <a:p>
+            <a:pPr marL="285750" indent="-285750">
+              <a:buFont typeface="Arial" panose="020B0604020202020204" pitchFamily="34" charset="0"/>
+              <a:buChar char="•"/>
+            </a:pPr>
+            <a:r>
+              <a:rPr lang="en-US" dirty="0"/>
+              <a:t>SLC complete Point Target Analysis and benchmarking with old SCT		</a:t>
             </a:r>
             <a:r>
               <a:rPr lang="en-US" dirty="0">
@@ -16541,86 +17017,7 @@
             </a:pPr>
             <a:r>
               <a:rPr lang="en-US" dirty="0"/>
-              <a:t>refactoring to allow new </a:t>
-            </a:r>
-            <a:r>
-              <a:rPr lang="en-US" dirty="0" err="1"/>
-              <a:t>Aresys</a:t>
-            </a:r>
-            <a:r>
-              <a:rPr lang="en-US" dirty="0"/>
-              <a:t> product folder format from </a:t>
-            </a:r>
-            <a:r>
-              <a:rPr lang="en-US" dirty="0" err="1"/>
-              <a:t>arepytools</a:t>
-            </a:r>
-            <a:r>
-              <a:rPr lang="en-US" dirty="0">
-                <a:solidFill>
-                  <a:srgbClr val="00B050"/>
-                </a:solidFill>
-              </a:rPr>
-              <a:t>		[DONE]</a:t>
-            </a:r>
-            <a:endParaRPr lang="en-US" dirty="0">
-              <a:solidFill>
-                <a:srgbClr val="C00000"/>
-              </a:solidFill>
-            </a:endParaRPr>
-          </a:p>
-        </p:txBody>
-      </p:sp>
-      <p:sp>
-        <p:nvSpPr>
-          <p:cNvPr id="8" name="TextBox 7">
-            <a:extLst>
-              <a:ext uri="{FF2B5EF4-FFF2-40B4-BE49-F238E27FC236}">
-                <a16:creationId xmlns:a16="http://schemas.microsoft.com/office/drawing/2014/main" id="{F2CB62A5-28A3-DC91-954B-F04A7E97FBD4}"/>
-              </a:ext>
-            </a:extLst>
-          </p:cNvPr>
-          <p:cNvSpPr txBox="1"/>
-          <p:nvPr/>
-        </p:nvSpPr>
-        <p:spPr>
-          <a:xfrm>
-            <a:off x="1026366" y="1280806"/>
-            <a:ext cx="10795519" cy="923330"/>
-          </a:xfrm>
-          <a:prstGeom prst="rect">
-            <a:avLst/>
-          </a:prstGeom>
-          <a:noFill/>
-        </p:spPr>
-        <p:txBody>
-          <a:bodyPr wrap="square" rtlCol="0">
-            <a:spAutoFit/>
-          </a:bodyPr>
-          <a:lstStyle/>
-          <a:p>
-            <a:r>
-              <a:rPr lang="en-US" b="1" cap="small" dirty="0" err="1"/>
-              <a:t>Arepytools</a:t>
-            </a:r>
-            <a:endParaRPr lang="en-US" b="1" cap="small" dirty="0"/>
-          </a:p>
-          <a:p>
-            <a:pPr marL="285750" indent="-285750">
-              <a:buFont typeface="Arial" panose="020B0604020202020204" pitchFamily="34" charset="0"/>
-              <a:buChar char="•"/>
-            </a:pPr>
-            <a:r>
-              <a:rPr lang="en-US" dirty="0"/>
-              <a:t>new </a:t>
-            </a:r>
-            <a:r>
-              <a:rPr lang="en-US" dirty="0" err="1"/>
-              <a:t>Aresys</a:t>
-            </a:r>
-            <a:r>
-              <a:rPr lang="en-US" dirty="0"/>
-              <a:t> product folder format implementation				</a:t>
+              <a:t>GRD complete Point Target Analysis and benchmarking with old SCT		</a:t>
             </a:r>
             <a:r>
               <a:rPr lang="en-US" dirty="0">
@@ -16630,318 +17027,13 @@
               </a:rPr>
               <a:t>[DONE]</a:t>
             </a:r>
-            <a:endParaRPr lang="en-US" dirty="0">
-              <a:solidFill>
-                <a:srgbClr val="0070C0"/>
-              </a:solidFill>
-            </a:endParaRPr>
-          </a:p>
-          <a:p>
-            <a:pPr marL="285750" indent="-285750">
-              <a:buFont typeface="Arial" panose="020B0604020202020204" pitchFamily="34" charset="0"/>
-              <a:buChar char="•"/>
-            </a:pPr>
-            <a:r>
-              <a:rPr lang="en-US" dirty="0"/>
-              <a:t>new internal point target products management implementation</a:t>
-            </a:r>
-            <a:r>
-              <a:rPr lang="en-US" dirty="0">
-                <a:solidFill>
-                  <a:srgbClr val="0070C0"/>
-                </a:solidFill>
-              </a:rPr>
-              <a:t>			</a:t>
-            </a:r>
-            <a:r>
-              <a:rPr lang="en-US" dirty="0">
-                <a:solidFill>
-                  <a:srgbClr val="00B050"/>
-                </a:solidFill>
-              </a:rPr>
-              <a:t>[DONE]</a:t>
-            </a:r>
-          </a:p>
-        </p:txBody>
-      </p:sp>
-      <p:sp>
-        <p:nvSpPr>
-          <p:cNvPr id="9" name="TextBox 8">
-            <a:extLst>
-              <a:ext uri="{FF2B5EF4-FFF2-40B4-BE49-F238E27FC236}">
-                <a16:creationId xmlns:a16="http://schemas.microsoft.com/office/drawing/2014/main" id="{DB88366A-867E-0FC6-09B2-2DF8BB3E76E9}"/>
-              </a:ext>
-            </a:extLst>
-          </p:cNvPr>
-          <p:cNvSpPr txBox="1"/>
-          <p:nvPr/>
-        </p:nvSpPr>
-        <p:spPr>
-          <a:xfrm>
-            <a:off x="1026364" y="3611792"/>
-            <a:ext cx="10795519" cy="3139321"/>
-          </a:xfrm>
-          <a:prstGeom prst="rect">
-            <a:avLst/>
-          </a:prstGeom>
-          <a:noFill/>
-        </p:spPr>
-        <p:txBody>
-          <a:bodyPr wrap="square" rtlCol="0">
-            <a:spAutoFit/>
-          </a:bodyPr>
-          <a:lstStyle/>
-          <a:p>
-            <a:r>
-              <a:rPr lang="en-US" b="1" cap="small" dirty="0"/>
-              <a:t>SCT</a:t>
-            </a:r>
-          </a:p>
-          <a:p>
-            <a:pPr marL="285750" indent="-285750">
-              <a:buFont typeface="Arial" panose="020B0604020202020204" pitchFamily="34" charset="0"/>
-              <a:buChar char="•"/>
-            </a:pPr>
-            <a:r>
-              <a:rPr lang="en-US" dirty="0"/>
-              <a:t>perturbations management: understand where and how	</a:t>
-            </a:r>
-            <a:r>
-              <a:rPr lang="en-US" dirty="0">
-                <a:solidFill>
-                  <a:srgbClr val="C00000"/>
-                </a:solidFill>
-              </a:rPr>
-              <a:t>			</a:t>
-            </a:r>
-            <a:r>
-              <a:rPr lang="en-US" dirty="0">
-                <a:solidFill>
-                  <a:srgbClr val="00B050"/>
-                </a:solidFill>
-              </a:rPr>
-              <a:t>[DONE]</a:t>
-            </a:r>
-          </a:p>
-          <a:p>
-            <a:pPr marL="285750" indent="-285750">
-              <a:buFont typeface="Arial" panose="020B0604020202020204" pitchFamily="34" charset="0"/>
-              <a:buChar char="•"/>
-            </a:pPr>
-            <a:r>
-              <a:rPr lang="en-US" dirty="0"/>
-              <a:t>time corrections management: understand where and how</a:t>
-            </a:r>
-            <a:r>
-              <a:rPr lang="en-US" dirty="0">
-                <a:solidFill>
-                  <a:srgbClr val="C00000"/>
-                </a:solidFill>
-              </a:rPr>
-              <a:t>			</a:t>
-            </a:r>
-            <a:r>
-              <a:rPr lang="en-US" dirty="0">
-                <a:solidFill>
-                  <a:srgbClr val="00B050"/>
-                </a:solidFill>
-              </a:rPr>
-              <a:t>[DONE]</a:t>
-            </a:r>
-            <a:endParaRPr lang="en-US" dirty="0"/>
-          </a:p>
-          <a:p>
-            <a:pPr marL="285750" indent="-285750">
-              <a:buFont typeface="Arial" panose="020B0604020202020204" pitchFamily="34" charset="0"/>
-              <a:buChar char="•"/>
-            </a:pPr>
-            <a:r>
-              <a:rPr lang="en-US" dirty="0"/>
-              <a:t>calibration sites SQLite database schema definition				</a:t>
-            </a:r>
-            <a:r>
-              <a:rPr lang="en-US" dirty="0">
-                <a:solidFill>
-                  <a:srgbClr val="00B050"/>
-                </a:solidFill>
-              </a:rPr>
-              <a:t>[DONE]</a:t>
-            </a:r>
-          </a:p>
-          <a:p>
-            <a:pPr marL="285750" indent="-285750">
-              <a:buFont typeface="Arial" panose="020B0604020202020204" pitchFamily="34" charset="0"/>
-              <a:buChar char="•"/>
-            </a:pPr>
-            <a:r>
-              <a:rPr lang="en-US" dirty="0"/>
-              <a:t>create a new internal repository to host the project</a:t>
-            </a:r>
-            <a:r>
-              <a:rPr lang="en-US" dirty="0">
-                <a:solidFill>
-                  <a:srgbClr val="C00000"/>
-                </a:solidFill>
-              </a:rPr>
-              <a:t>				</a:t>
-            </a:r>
-            <a:r>
-              <a:rPr lang="en-US" dirty="0">
-                <a:solidFill>
-                  <a:srgbClr val="00B050"/>
-                </a:solidFill>
-              </a:rPr>
-              <a:t>[DONE]</a:t>
-            </a:r>
-            <a:endParaRPr lang="en-US" dirty="0">
-              <a:solidFill>
-                <a:srgbClr val="C00000"/>
-              </a:solidFill>
-            </a:endParaRPr>
-          </a:p>
-          <a:p>
-            <a:pPr marL="285750" indent="-285750">
-              <a:buFont typeface="Arial" panose="020B0604020202020204" pitchFamily="34" charset="0"/>
-              <a:buChar char="•"/>
-            </a:pPr>
-            <a:r>
-              <a:rPr lang="en-US" dirty="0"/>
-              <a:t>external orbits management: understand where and how</a:t>
-            </a:r>
-            <a:r>
-              <a:rPr lang="en-US" dirty="0">
-                <a:solidFill>
-                  <a:srgbClr val="C00000"/>
-                </a:solidFill>
-              </a:rPr>
-              <a:t>			</a:t>
-            </a:r>
-            <a:r>
-              <a:rPr lang="en-US" dirty="0">
-                <a:solidFill>
-                  <a:srgbClr val="00B050"/>
-                </a:solidFill>
-              </a:rPr>
-              <a:t>[DONE]</a:t>
-            </a:r>
-          </a:p>
-          <a:p>
-            <a:pPr marL="285750" indent="-285750">
-              <a:buFont typeface="Arial" panose="020B0604020202020204" pitchFamily="34" charset="0"/>
-              <a:buChar char="•"/>
-            </a:pPr>
-            <a:r>
-              <a:rPr lang="en-US" dirty="0"/>
-              <a:t>SAFE reader, compliant with input protocol</a:t>
-            </a:r>
-            <a:r>
-              <a:rPr lang="en-US" dirty="0">
-                <a:solidFill>
-                  <a:srgbClr val="00B050"/>
-                </a:solidFill>
-              </a:rPr>
-              <a:t>					[DONE]</a:t>
-            </a:r>
-          </a:p>
-          <a:p>
-            <a:pPr marL="285750" indent="-285750">
-              <a:buFont typeface="Arial" panose="020B0604020202020204" pitchFamily="34" charset="0"/>
-              <a:buChar char="•"/>
-            </a:pPr>
-            <a:r>
-              <a:rPr lang="en-US" dirty="0"/>
-              <a:t>calibration sites SQLite database schema definition				</a:t>
-            </a:r>
-            <a:r>
-              <a:rPr lang="en-US" dirty="0">
-                <a:solidFill>
-                  <a:srgbClr val="00B050"/>
-                </a:solidFill>
-              </a:rPr>
-              <a:t>[DONE]</a:t>
-            </a:r>
-          </a:p>
-          <a:p>
-            <a:pPr marL="285750" indent="-285750">
-              <a:buFont typeface="Arial" panose="020B0604020202020204" pitchFamily="34" charset="0"/>
-              <a:buChar char="•"/>
-            </a:pPr>
-            <a:r>
-              <a:rPr lang="en-US" dirty="0"/>
-              <a:t>SQLite calibration site generation (scripts + DB)</a:t>
-            </a:r>
-            <a:r>
-              <a:rPr lang="en-US" dirty="0">
-                <a:solidFill>
-                  <a:srgbClr val="00B050"/>
-                </a:solidFill>
-              </a:rPr>
-              <a:t>					[DONE]</a:t>
-            </a:r>
-          </a:p>
-          <a:p>
-            <a:pPr marL="285750" indent="-285750">
-              <a:buFont typeface="Arial" panose="020B0604020202020204" pitchFamily="34" charset="0"/>
-              <a:buChar char="•"/>
-            </a:pPr>
-            <a:r>
-              <a:rPr lang="en-US" dirty="0"/>
-              <a:t>external orbits management: understand where and how</a:t>
-            </a:r>
-            <a:r>
-              <a:rPr lang="en-US" dirty="0">
-                <a:solidFill>
-                  <a:srgbClr val="C00000"/>
-                </a:solidFill>
-              </a:rPr>
-              <a:t>			</a:t>
-            </a:r>
-            <a:r>
-              <a:rPr lang="en-US" dirty="0">
-                <a:solidFill>
-                  <a:srgbClr val="00B050"/>
-                </a:solidFill>
-              </a:rPr>
-              <a:t>[DONE]</a:t>
-            </a:r>
-          </a:p>
-          <a:p>
-            <a:pPr marL="285750" indent="-285750">
-              <a:buFont typeface="Arial" panose="020B0604020202020204" pitchFamily="34" charset="0"/>
-              <a:buChar char="•"/>
-            </a:pPr>
-            <a:r>
-              <a:rPr lang="en-US" dirty="0"/>
-              <a:t>external orbits module (specific for sentinel-1) implementation</a:t>
-            </a:r>
-            <a:r>
-              <a:rPr lang="en-US" dirty="0">
-                <a:solidFill>
-                  <a:srgbClr val="C00000"/>
-                </a:solidFill>
-              </a:rPr>
-              <a:t>			</a:t>
-            </a:r>
-            <a:r>
-              <a:rPr lang="en-US" dirty="0">
-                <a:solidFill>
-                  <a:srgbClr val="00B050"/>
-                </a:solidFill>
-              </a:rPr>
-              <a:t>[DONE]</a:t>
-            </a:r>
-            <a:endParaRPr lang="en-US" dirty="0">
-              <a:solidFill>
-                <a:srgbClr val="C00000"/>
-              </a:solidFill>
-            </a:endParaRPr>
           </a:p>
         </p:txBody>
       </p:sp>
     </p:spTree>
     <p:extLst>
       <p:ext uri="{BB962C8B-B14F-4D97-AF65-F5344CB8AC3E}">
-        <p14:creationId xmlns:p14="http://schemas.microsoft.com/office/powerpoint/2010/main" val="3285187959"/>
+        <p14:creationId xmlns:p14="http://schemas.microsoft.com/office/powerpoint/2010/main" val="1731143031"/>
       </p:ext>
     </p:extLst>
   </p:cSld>
@@ -17002,7 +17094,470 @@
             </a:r>
             <a:r>
               <a:rPr lang="en-US" sz="3600" dirty="0"/>
-              <a:t>– COMPLETED TASKS 2/2</a:t>
+              <a:t>– COMPLETED TASKS 1/2</a:t>
+            </a:r>
+          </a:p>
+        </p:txBody>
+      </p:sp>
+      <p:sp>
+        <p:nvSpPr>
+          <p:cNvPr id="3" name="TextBox 2">
+            <a:extLst>
+              <a:ext uri="{FF2B5EF4-FFF2-40B4-BE49-F238E27FC236}">
+                <a16:creationId xmlns:a16="http://schemas.microsoft.com/office/drawing/2014/main" id="{585FE47C-A4FF-D018-2E69-4649505A0101}"/>
+              </a:ext>
+            </a:extLst>
+          </p:cNvPr>
+          <p:cNvSpPr txBox="1"/>
+          <p:nvPr/>
+        </p:nvSpPr>
+        <p:spPr>
+          <a:xfrm>
+            <a:off x="1026364" y="2446299"/>
+            <a:ext cx="10795519" cy="2031325"/>
+          </a:xfrm>
+          <a:prstGeom prst="rect">
+            <a:avLst/>
+          </a:prstGeom>
+          <a:noFill/>
+        </p:spPr>
+        <p:txBody>
+          <a:bodyPr wrap="square" rtlCol="0">
+            <a:spAutoFit/>
+          </a:bodyPr>
+          <a:lstStyle/>
+          <a:p>
+            <a:r>
+              <a:rPr lang="en-US" b="1" cap="small" dirty="0" err="1"/>
+              <a:t>Arepyextras</a:t>
+            </a:r>
+            <a:r>
+              <a:rPr lang="en-US" b="1" cap="small" dirty="0"/>
+              <a:t> Quality</a:t>
+            </a:r>
+          </a:p>
+          <a:p>
+            <a:pPr marL="285750" indent="-285750">
+              <a:buFont typeface="Arial" panose="020B0604020202020204" pitchFamily="34" charset="0"/>
+              <a:buChar char="•"/>
+            </a:pPr>
+            <a:r>
+              <a:rPr lang="en-US" dirty="0"/>
+              <a:t>refactoring to allow protocol-compliant input injection				</a:t>
+            </a:r>
+            <a:r>
+              <a:rPr lang="en-US" dirty="0">
+                <a:solidFill>
+                  <a:srgbClr val="00B050"/>
+                </a:solidFill>
+              </a:rPr>
+              <a:t>[DONE]</a:t>
+            </a:r>
+          </a:p>
+          <a:p>
+            <a:pPr marL="285750" indent="-285750">
+              <a:buFont typeface="Arial" panose="020B0604020202020204" pitchFamily="34" charset="0"/>
+              <a:buChar char="•"/>
+            </a:pPr>
+            <a:r>
+              <a:rPr lang="en-US" dirty="0"/>
+              <a:t>refactoring to allow new </a:t>
+            </a:r>
+            <a:r>
+              <a:rPr lang="en-US" dirty="0" err="1"/>
+              <a:t>Aresys</a:t>
+            </a:r>
+            <a:r>
+              <a:rPr lang="en-US" dirty="0"/>
+              <a:t> product folder format from </a:t>
+            </a:r>
+            <a:r>
+              <a:rPr lang="en-US" dirty="0" err="1"/>
+              <a:t>arepytools</a:t>
+            </a:r>
+            <a:r>
+              <a:rPr lang="en-US" dirty="0">
+                <a:solidFill>
+                  <a:srgbClr val="00B050"/>
+                </a:solidFill>
+              </a:rPr>
+              <a:t>		[DONE]</a:t>
+            </a:r>
+          </a:p>
+          <a:p>
+            <a:pPr marL="285750" indent="-285750">
+              <a:buFont typeface="Arial" panose="020B0604020202020204" pitchFamily="34" charset="0"/>
+              <a:buChar char="•"/>
+            </a:pPr>
+            <a:r>
+              <a:rPr lang="en-US" dirty="0"/>
+              <a:t>Radiometric Profiles (NESZ, Gamma, Scallop) implementation			</a:t>
+            </a:r>
+            <a:r>
+              <a:rPr lang="en-US" dirty="0">
+                <a:solidFill>
+                  <a:srgbClr val="00B050"/>
+                </a:solidFill>
+              </a:rPr>
+              <a:t>[DONE]</a:t>
+            </a:r>
+          </a:p>
+          <a:p>
+            <a:pPr marL="285750" indent="-285750">
+              <a:buFont typeface="Arial" panose="020B0604020202020204" pitchFamily="34" charset="0"/>
+              <a:buChar char="•"/>
+            </a:pPr>
+            <a:r>
+              <a:rPr lang="en-US" dirty="0"/>
+              <a:t>SCT legacy report conversion</a:t>
+            </a:r>
+            <a:r>
+              <a:rPr lang="en-US" dirty="0">
+                <a:solidFill>
+                  <a:srgbClr val="0070C0"/>
+                </a:solidFill>
+              </a:rPr>
+              <a:t>							</a:t>
+            </a:r>
+            <a:r>
+              <a:rPr lang="en-US" dirty="0">
+                <a:solidFill>
+                  <a:srgbClr val="00B050"/>
+                </a:solidFill>
+              </a:rPr>
+              <a:t>[DONE]</a:t>
+            </a:r>
+          </a:p>
+          <a:p>
+            <a:pPr marL="285750" indent="-285750">
+              <a:buFont typeface="Arial" panose="020B0604020202020204" pitchFamily="34" charset="0"/>
+              <a:buChar char="•"/>
+            </a:pPr>
+            <a:endParaRPr lang="en-US" dirty="0">
+              <a:solidFill>
+                <a:srgbClr val="00B050"/>
+              </a:solidFill>
+            </a:endParaRPr>
+          </a:p>
+          <a:p>
+            <a:pPr marL="285750" indent="-285750">
+              <a:buFont typeface="Arial" panose="020B0604020202020204" pitchFamily="34" charset="0"/>
+              <a:buChar char="•"/>
+            </a:pPr>
+            <a:endParaRPr lang="en-US" dirty="0">
+              <a:solidFill>
+                <a:srgbClr val="C00000"/>
+              </a:solidFill>
+            </a:endParaRPr>
+          </a:p>
+        </p:txBody>
+      </p:sp>
+      <p:sp>
+        <p:nvSpPr>
+          <p:cNvPr id="8" name="TextBox 7">
+            <a:extLst>
+              <a:ext uri="{FF2B5EF4-FFF2-40B4-BE49-F238E27FC236}">
+                <a16:creationId xmlns:a16="http://schemas.microsoft.com/office/drawing/2014/main" id="{F2CB62A5-28A3-DC91-954B-F04A7E97FBD4}"/>
+              </a:ext>
+            </a:extLst>
+          </p:cNvPr>
+          <p:cNvSpPr txBox="1"/>
+          <p:nvPr/>
+        </p:nvSpPr>
+        <p:spPr>
+          <a:xfrm>
+            <a:off x="1026366" y="1280806"/>
+            <a:ext cx="10795519" cy="923330"/>
+          </a:xfrm>
+          <a:prstGeom prst="rect">
+            <a:avLst/>
+          </a:prstGeom>
+          <a:noFill/>
+        </p:spPr>
+        <p:txBody>
+          <a:bodyPr wrap="square" rtlCol="0">
+            <a:spAutoFit/>
+          </a:bodyPr>
+          <a:lstStyle/>
+          <a:p>
+            <a:r>
+              <a:rPr lang="en-US" b="1" cap="small" dirty="0" err="1"/>
+              <a:t>Arepytools</a:t>
+            </a:r>
+            <a:endParaRPr lang="en-US" b="1" cap="small" dirty="0"/>
+          </a:p>
+          <a:p>
+            <a:pPr marL="285750" indent="-285750">
+              <a:buFont typeface="Arial" panose="020B0604020202020204" pitchFamily="34" charset="0"/>
+              <a:buChar char="•"/>
+            </a:pPr>
+            <a:r>
+              <a:rPr lang="en-US" dirty="0"/>
+              <a:t>new </a:t>
+            </a:r>
+            <a:r>
+              <a:rPr lang="en-US" dirty="0" err="1"/>
+              <a:t>Aresys</a:t>
+            </a:r>
+            <a:r>
+              <a:rPr lang="en-US" dirty="0"/>
+              <a:t> product folder format implementation				</a:t>
+            </a:r>
+            <a:r>
+              <a:rPr lang="en-US" dirty="0">
+                <a:solidFill>
+                  <a:srgbClr val="00B050"/>
+                </a:solidFill>
+              </a:rPr>
+              <a:t>[DONE]</a:t>
+            </a:r>
+            <a:endParaRPr lang="en-US" dirty="0">
+              <a:solidFill>
+                <a:srgbClr val="0070C0"/>
+              </a:solidFill>
+            </a:endParaRPr>
+          </a:p>
+          <a:p>
+            <a:pPr marL="285750" indent="-285750">
+              <a:buFont typeface="Arial" panose="020B0604020202020204" pitchFamily="34" charset="0"/>
+              <a:buChar char="•"/>
+            </a:pPr>
+            <a:r>
+              <a:rPr lang="en-US" dirty="0"/>
+              <a:t>new internal point target products management implementation</a:t>
+            </a:r>
+            <a:r>
+              <a:rPr lang="en-US" dirty="0">
+                <a:solidFill>
+                  <a:srgbClr val="0070C0"/>
+                </a:solidFill>
+              </a:rPr>
+              <a:t>			</a:t>
+            </a:r>
+            <a:r>
+              <a:rPr lang="en-US" dirty="0">
+                <a:solidFill>
+                  <a:srgbClr val="00B050"/>
+                </a:solidFill>
+              </a:rPr>
+              <a:t>[DONE]</a:t>
+            </a:r>
+          </a:p>
+        </p:txBody>
+      </p:sp>
+      <p:sp>
+        <p:nvSpPr>
+          <p:cNvPr id="9" name="TextBox 8">
+            <a:extLst>
+              <a:ext uri="{FF2B5EF4-FFF2-40B4-BE49-F238E27FC236}">
+                <a16:creationId xmlns:a16="http://schemas.microsoft.com/office/drawing/2014/main" id="{DB88366A-867E-0FC6-09B2-2DF8BB3E76E9}"/>
+              </a:ext>
+            </a:extLst>
+          </p:cNvPr>
+          <p:cNvSpPr txBox="1"/>
+          <p:nvPr/>
+        </p:nvSpPr>
+        <p:spPr>
+          <a:xfrm>
+            <a:off x="1026363" y="4097333"/>
+            <a:ext cx="10795519" cy="2585323"/>
+          </a:xfrm>
+          <a:prstGeom prst="rect">
+            <a:avLst/>
+          </a:prstGeom>
+          <a:noFill/>
+        </p:spPr>
+        <p:txBody>
+          <a:bodyPr wrap="square" rtlCol="0">
+            <a:spAutoFit/>
+          </a:bodyPr>
+          <a:lstStyle/>
+          <a:p>
+            <a:r>
+              <a:rPr lang="en-US" b="1" cap="small" dirty="0"/>
+              <a:t>SCT 1/2</a:t>
+            </a:r>
+          </a:p>
+          <a:p>
+            <a:pPr marL="285750" indent="-285750">
+              <a:buFont typeface="Arial" panose="020B0604020202020204" pitchFamily="34" charset="0"/>
+              <a:buChar char="•"/>
+            </a:pPr>
+            <a:r>
+              <a:rPr lang="en-US" dirty="0"/>
+              <a:t>perturbations management: understand where and how	</a:t>
+            </a:r>
+            <a:r>
+              <a:rPr lang="en-US" dirty="0">
+                <a:solidFill>
+                  <a:srgbClr val="C00000"/>
+                </a:solidFill>
+              </a:rPr>
+              <a:t>			</a:t>
+            </a:r>
+            <a:r>
+              <a:rPr lang="en-US" dirty="0">
+                <a:solidFill>
+                  <a:srgbClr val="00B050"/>
+                </a:solidFill>
+              </a:rPr>
+              <a:t>[DONE]</a:t>
+            </a:r>
+          </a:p>
+          <a:p>
+            <a:pPr marL="285750" indent="-285750">
+              <a:buFont typeface="Arial" panose="020B0604020202020204" pitchFamily="34" charset="0"/>
+              <a:buChar char="•"/>
+            </a:pPr>
+            <a:r>
+              <a:rPr lang="en-US" dirty="0"/>
+              <a:t>time corrections management: understand where and how</a:t>
+            </a:r>
+            <a:r>
+              <a:rPr lang="en-US" dirty="0">
+                <a:solidFill>
+                  <a:srgbClr val="C00000"/>
+                </a:solidFill>
+              </a:rPr>
+              <a:t>			</a:t>
+            </a:r>
+            <a:r>
+              <a:rPr lang="en-US" dirty="0">
+                <a:solidFill>
+                  <a:srgbClr val="00B050"/>
+                </a:solidFill>
+              </a:rPr>
+              <a:t>[DONE]</a:t>
+            </a:r>
+            <a:endParaRPr lang="en-US" dirty="0"/>
+          </a:p>
+          <a:p>
+            <a:pPr marL="285750" indent="-285750">
+              <a:buFont typeface="Arial" panose="020B0604020202020204" pitchFamily="34" charset="0"/>
+              <a:buChar char="•"/>
+            </a:pPr>
+            <a:r>
+              <a:rPr lang="en-US" dirty="0"/>
+              <a:t>calibration sites SQLite database schema definition				</a:t>
+            </a:r>
+            <a:r>
+              <a:rPr lang="en-US" dirty="0">
+                <a:solidFill>
+                  <a:srgbClr val="00B050"/>
+                </a:solidFill>
+              </a:rPr>
+              <a:t>[DONE]</a:t>
+            </a:r>
+          </a:p>
+          <a:p>
+            <a:pPr marL="285750" indent="-285750">
+              <a:buFont typeface="Arial" panose="020B0604020202020204" pitchFamily="34" charset="0"/>
+              <a:buChar char="•"/>
+            </a:pPr>
+            <a:r>
+              <a:rPr lang="en-US" dirty="0"/>
+              <a:t>create a new internal repository to host the project</a:t>
+            </a:r>
+            <a:r>
+              <a:rPr lang="en-US" dirty="0">
+                <a:solidFill>
+                  <a:srgbClr val="C00000"/>
+                </a:solidFill>
+              </a:rPr>
+              <a:t>				</a:t>
+            </a:r>
+            <a:r>
+              <a:rPr lang="en-US" dirty="0">
+                <a:solidFill>
+                  <a:srgbClr val="00B050"/>
+                </a:solidFill>
+              </a:rPr>
+              <a:t>[DONE]</a:t>
+            </a:r>
+            <a:endParaRPr lang="en-US" dirty="0">
+              <a:solidFill>
+                <a:srgbClr val="C00000"/>
+              </a:solidFill>
+            </a:endParaRPr>
+          </a:p>
+          <a:p>
+            <a:pPr marL="285750" indent="-285750">
+              <a:buFont typeface="Arial" panose="020B0604020202020204" pitchFamily="34" charset="0"/>
+              <a:buChar char="•"/>
+            </a:pPr>
+            <a:r>
+              <a:rPr lang="en-US" dirty="0"/>
+              <a:t>external orbits management: understand where and how</a:t>
+            </a:r>
+            <a:r>
+              <a:rPr lang="en-US" dirty="0">
+                <a:solidFill>
+                  <a:srgbClr val="C00000"/>
+                </a:solidFill>
+              </a:rPr>
+              <a:t>			</a:t>
+            </a:r>
+            <a:r>
+              <a:rPr lang="en-US" dirty="0">
+                <a:solidFill>
+                  <a:srgbClr val="00B050"/>
+                </a:solidFill>
+              </a:rPr>
+              <a:t>[DONE]</a:t>
+            </a:r>
+          </a:p>
+          <a:p>
+            <a:pPr marL="285750" indent="-285750">
+              <a:buFont typeface="Arial" panose="020B0604020202020204" pitchFamily="34" charset="0"/>
+              <a:buChar char="•"/>
+            </a:pPr>
+            <a:r>
+              <a:rPr lang="en-US" dirty="0"/>
+              <a:t>SAFE reader, compliant with input protocol</a:t>
+            </a:r>
+            <a:r>
+              <a:rPr lang="en-US" dirty="0">
+                <a:solidFill>
+                  <a:srgbClr val="00B050"/>
+                </a:solidFill>
+              </a:rPr>
+              <a:t>					[DONE]</a:t>
+            </a:r>
+          </a:p>
+          <a:p>
+            <a:pPr marL="285750" indent="-285750">
+              <a:buFont typeface="Arial" panose="020B0604020202020204" pitchFamily="34" charset="0"/>
+              <a:buChar char="•"/>
+            </a:pPr>
+            <a:r>
+              <a:rPr lang="en-US" dirty="0"/>
+              <a:t>calibration sites SQLite database schema definition				</a:t>
+            </a:r>
+            <a:r>
+              <a:rPr lang="en-US" dirty="0">
+                <a:solidFill>
+                  <a:srgbClr val="00B050"/>
+                </a:solidFill>
+              </a:rPr>
+              <a:t>[DONE]</a:t>
+            </a:r>
+          </a:p>
+          <a:p>
+            <a:pPr marL="285750" indent="-285750">
+              <a:buFont typeface="Arial" panose="020B0604020202020204" pitchFamily="34" charset="0"/>
+              <a:buChar char="•"/>
+            </a:pPr>
+            <a:r>
+              <a:rPr lang="en-US" dirty="0"/>
+              <a:t>SQLite calibration site generation (scripts + DB)</a:t>
+            </a:r>
+            <a:r>
+              <a:rPr lang="en-US" dirty="0">
+                <a:solidFill>
+                  <a:srgbClr val="00B050"/>
+                </a:solidFill>
+              </a:rPr>
+              <a:t>					[DONE]</a:t>
             </a:r>
           </a:p>
         </p:txBody>
@@ -17010,7 +17565,7 @@
     </p:spTree>
     <p:extLst>
       <p:ext uri="{BB962C8B-B14F-4D97-AF65-F5344CB8AC3E}">
-        <p14:creationId xmlns:p14="http://schemas.microsoft.com/office/powerpoint/2010/main" val="4178585589"/>
+        <p14:creationId xmlns:p14="http://schemas.microsoft.com/office/powerpoint/2010/main" val="3285187959"/>
       </p:ext>
     </p:extLst>
   </p:cSld>
@@ -17067,11 +17622,11 @@
           <a:p>
             <a:r>
               <a:rPr lang="en-US" sz="3600" cap="small" dirty="0"/>
-              <a:t>Private side </a:t>
+              <a:t>Private Side </a:t>
             </a:r>
             <a:r>
               <a:rPr lang="en-US" sz="3600" dirty="0"/>
-              <a:t>– Radiometric Analysis</a:t>
+              <a:t>– COMPLETED TASKS 2/2</a:t>
             </a:r>
           </a:p>
         </p:txBody>
@@ -17081,7 +17636,7 @@
           <p:cNvPr id="3" name="TextBox 2">
             <a:extLst>
               <a:ext uri="{FF2B5EF4-FFF2-40B4-BE49-F238E27FC236}">
-                <a16:creationId xmlns:a16="http://schemas.microsoft.com/office/drawing/2014/main" id="{585FE47C-A4FF-D018-2E69-4649505A0101}"/>
+                <a16:creationId xmlns:a16="http://schemas.microsoft.com/office/drawing/2014/main" id="{871B552B-30A3-281A-18C8-D5C2DDB5507E}"/>
               </a:ext>
             </a:extLst>
           </p:cNvPr>
@@ -17090,8 +17645,8 @@
         </p:nvSpPr>
         <p:spPr>
           <a:xfrm>
-            <a:off x="942391" y="2412547"/>
-            <a:ext cx="10795519" cy="1338828"/>
+            <a:off x="1000485" y="1144637"/>
+            <a:ext cx="10795519" cy="1477328"/>
           </a:xfrm>
           <a:prstGeom prst="rect">
             <a:avLst/>
@@ -17104,75 +17659,90 @@
           </a:bodyPr>
           <a:lstStyle/>
           <a:p>
-            <a:pPr marL="457200" indent="-457200">
-              <a:spcAft>
-                <a:spcPts val="3000"/>
-              </a:spcAft>
+            <a:r>
+              <a:rPr lang="en-US" b="1" cap="small" dirty="0"/>
+              <a:t>SCT 2/2</a:t>
+            </a:r>
+          </a:p>
+          <a:p>
+            <a:endParaRPr lang="en-US" b="1" cap="small" dirty="0"/>
+          </a:p>
+          <a:p>
+            <a:pPr marL="285750" indent="-285750">
               <a:buFont typeface="Arial" panose="020B0604020202020204" pitchFamily="34" charset="0"/>
               <a:buChar char="•"/>
             </a:pPr>
             <a:r>
-              <a:rPr lang="en-US" sz="2800" dirty="0"/>
-              <a:t>Define new radiometric analysis process</a:t>
-            </a:r>
-          </a:p>
-          <a:p>
-            <a:pPr marL="457200" indent="-457200">
-              <a:spcAft>
-                <a:spcPts val="3000"/>
-              </a:spcAft>
+              <a:rPr lang="en-US" dirty="0"/>
+              <a:t>external orbits management: understand where and how</a:t>
+            </a:r>
+            <a:r>
+              <a:rPr lang="en-US" dirty="0">
+                <a:solidFill>
+                  <a:srgbClr val="C00000"/>
+                </a:solidFill>
+              </a:rPr>
+              <a:t>			</a:t>
+            </a:r>
+            <a:r>
+              <a:rPr lang="en-US" dirty="0">
+                <a:solidFill>
+                  <a:srgbClr val="00B050"/>
+                </a:solidFill>
+              </a:rPr>
+              <a:t>[DONE]</a:t>
+            </a:r>
+          </a:p>
+          <a:p>
+            <a:pPr marL="285750" indent="-285750">
               <a:buFont typeface="Arial" panose="020B0604020202020204" pitchFamily="34" charset="0"/>
               <a:buChar char="•"/>
             </a:pPr>
             <a:r>
-              <a:rPr lang="en-US" sz="2800" dirty="0"/>
-              <a:t>Radiometric + Gamma output: NETCDF? graphs?</a:t>
-            </a:r>
-          </a:p>
-        </p:txBody>
-      </p:sp>
-      <p:sp>
-        <p:nvSpPr>
-          <p:cNvPr id="4" name="TextBox 3">
-            <a:extLst>
-              <a:ext uri="{FF2B5EF4-FFF2-40B4-BE49-F238E27FC236}">
-                <a16:creationId xmlns:a16="http://schemas.microsoft.com/office/drawing/2014/main" id="{71D1F55A-C667-B0F5-1D6D-EC547AD40213}"/>
-              </a:ext>
-            </a:extLst>
-          </p:cNvPr>
-          <p:cNvSpPr txBox="1"/>
-          <p:nvPr/>
-        </p:nvSpPr>
-        <p:spPr>
-          <a:xfrm>
-            <a:off x="3054220" y="1239712"/>
-            <a:ext cx="6083559" cy="646331"/>
-          </a:xfrm>
-          <a:prstGeom prst="rect">
-            <a:avLst/>
-          </a:prstGeom>
-          <a:noFill/>
-          <a:ln w="38100">
-            <a:solidFill>
-              <a:srgbClr val="FF0000"/>
-            </a:solidFill>
-          </a:ln>
-        </p:spPr>
-        <p:txBody>
-          <a:bodyPr wrap="square" rtlCol="0">
-            <a:spAutoFit/>
-          </a:bodyPr>
-          <a:lstStyle/>
-          <a:p>
-            <a:pPr algn="ctr"/>
-            <a:r>
-              <a:rPr lang="en-US" sz="3600" b="1" dirty="0">
+              <a:rPr lang="en-US" dirty="0"/>
+              <a:t>external orbits module (specific for sentinel-1) implementation</a:t>
+            </a:r>
+            <a:r>
+              <a:rPr lang="en-US" dirty="0">
                 <a:solidFill>
                   <a:srgbClr val="C00000"/>
                 </a:solidFill>
-                <a:latin typeface="Amasis MT Pro Black" panose="020F0502020204030204" pitchFamily="18" charset="0"/>
               </a:rPr>
-              <a:t>INFORMATION NEEDED</a:t>
+              <a:t>			</a:t>
+            </a:r>
+            <a:r>
+              <a:rPr lang="en-US" dirty="0">
+                <a:solidFill>
+                  <a:srgbClr val="00B050"/>
+                </a:solidFill>
+              </a:rPr>
+              <a:t>[DONE]</a:t>
+            </a:r>
+          </a:p>
+          <a:p>
+            <a:pPr marL="285750" indent="-285750">
+              <a:buFont typeface="Arial" panose="020B0604020202020204" pitchFamily="34" charset="0"/>
+              <a:buChar char="•"/>
+            </a:pPr>
+            <a:r>
+              <a:rPr lang="en-US" dirty="0"/>
+              <a:t>time corrections module (specific for sentinel-1) implementation	</a:t>
+            </a:r>
+            <a:r>
+              <a:rPr lang="en-US" dirty="0">
+                <a:solidFill>
+                  <a:srgbClr val="C00000"/>
+                </a:solidFill>
+              </a:rPr>
+              <a:t>		</a:t>
+            </a:r>
+            <a:r>
+              <a:rPr lang="en-US" dirty="0">
+                <a:solidFill>
+                  <a:srgbClr val="00B050"/>
+                </a:solidFill>
+              </a:rPr>
+              <a:t>[DONE]</a:t>
             </a:r>
           </a:p>
         </p:txBody>
@@ -17180,7 +17750,7 @@
     </p:spTree>
     <p:extLst>
       <p:ext uri="{BB962C8B-B14F-4D97-AF65-F5344CB8AC3E}">
-        <p14:creationId xmlns:p14="http://schemas.microsoft.com/office/powerpoint/2010/main" val="2273917939"/>
+        <p14:creationId xmlns:p14="http://schemas.microsoft.com/office/powerpoint/2010/main" val="4178585589"/>
       </p:ext>
     </p:extLst>
   </p:cSld>

</xml_diff>

<commit_message>
arepyextras-quality 1.2.0 and arepyextras-eo_products 1.0.0 support added, documentation updated
</commit_message>
<xml_diff>
--- a/documentation/new_sct_status_update.pptx
+++ b/documentation/new_sct_status_update.pptx
@@ -270,7 +270,7 @@
           <a:p>
             <a:fld id="{5EA28068-AFBD-4979-B752-9EB6F90B1386}" type="datetimeFigureOut">
               <a:rPr lang="en-US" smtClean="0"/>
-              <a:t>2/12/2024</a:t>
+              <a:t>14-Mar-24</a:t>
             </a:fld>
             <a:endParaRPr lang="en-US" dirty="0"/>
           </a:p>
@@ -11302,7 +11302,7 @@
                   <a:schemeClr val="bg1"/>
                 </a:solidFill>
               </a:rPr>
-              <a:t>v1.5</a:t>
+              <a:t>v1.6</a:t>
             </a:r>
             <a:endParaRPr lang="en-US" dirty="0"/>
           </a:p>
@@ -14370,10 +14370,10 @@
       </p:sp>
       <p:pic>
         <p:nvPicPr>
-          <p:cNvPr id="4" name="Picture 3" descr="A diagram of a diagram&#10;&#10;Description automatically generated">
-            <a:extLst>
-              <a:ext uri="{FF2B5EF4-FFF2-40B4-BE49-F238E27FC236}">
-                <a16:creationId xmlns:a16="http://schemas.microsoft.com/office/drawing/2014/main" id="{040429A6-281E-2D71-8413-1B1A515B97D7}"/>
+          <p:cNvPr id="6" name="Picture 5" descr="A diagram of a diagram&#10;&#10;Description automatically generated">
+            <a:extLst>
+              <a:ext uri="{FF2B5EF4-FFF2-40B4-BE49-F238E27FC236}">
+                <a16:creationId xmlns:a16="http://schemas.microsoft.com/office/drawing/2014/main" id="{001E4E7F-4348-61B3-B7BD-E86D50112B38}"/>
               </a:ext>
             </a:extLst>
           </p:cNvPr>
@@ -14390,49 +14390,14 @@
         </p:blipFill>
         <p:spPr>
           <a:xfrm>
-            <a:off x="1713852" y="1156438"/>
-            <a:ext cx="8793122" cy="5467118"/>
+            <a:off x="1669776" y="1163773"/>
+            <a:ext cx="9460043" cy="5426371"/>
           </a:xfrm>
           <a:prstGeom prst="rect">
             <a:avLst/>
           </a:prstGeom>
         </p:spPr>
       </p:pic>
-      <p:sp>
-        <p:nvSpPr>
-          <p:cNvPr id="3" name="TextBox 2">
-            <a:extLst>
-              <a:ext uri="{FF2B5EF4-FFF2-40B4-BE49-F238E27FC236}">
-                <a16:creationId xmlns:a16="http://schemas.microsoft.com/office/drawing/2014/main" id="{0B78A589-559E-9E20-AC5F-62A8C9D09FAA}"/>
-              </a:ext>
-            </a:extLst>
-          </p:cNvPr>
-          <p:cNvSpPr txBox="1"/>
-          <p:nvPr/>
-        </p:nvSpPr>
-        <p:spPr>
-          <a:xfrm>
-            <a:off x="8307237" y="4597880"/>
-            <a:ext cx="560717" cy="646331"/>
-          </a:xfrm>
-          <a:prstGeom prst="rect">
-            <a:avLst/>
-          </a:prstGeom>
-          <a:noFill/>
-        </p:spPr>
-        <p:txBody>
-          <a:bodyPr wrap="square" rtlCol="0">
-            <a:spAutoFit/>
-          </a:bodyPr>
-          <a:lstStyle/>
-          <a:p>
-            <a:r>
-              <a:rPr lang="en-US" sz="3600" b="1" dirty="0"/>
-              <a:t>?</a:t>
-            </a:r>
-          </a:p>
-        </p:txBody>
-      </p:sp>
     </p:spTree>
     <p:extLst>
       <p:ext uri="{BB962C8B-B14F-4D97-AF65-F5344CB8AC3E}">
@@ -18257,6 +18222,15 @@
 </file>
 
 <file path=customXml/item1.xml><?xml version="1.0" encoding="utf-8"?>
+<?mso-contentType ?>
+<FormTemplates xmlns="http://schemas.microsoft.com/sharepoint/v3/contenttype/forms">
+  <Display>DocumentLibraryForm</Display>
+  <Edit>DocumentLibraryForm</Edit>
+  <New>DocumentLibraryForm</New>
+</FormTemplates>
+</file>
+
+<file path=customXml/item2.xml><?xml version="1.0" encoding="utf-8"?>
 <p:properties xmlns:p="http://schemas.microsoft.com/office/2006/metadata/properties" xmlns:xsi="http://www.w3.org/2001/XMLSchema-instance" xmlns:pc="http://schemas.microsoft.com/office/infopath/2007/PartnerControls">
   <documentManagement>
     <Status xmlns="71af3243-3dd4-4a8d-8c0d-dd76da1f02a5">Not started</Status>
@@ -18274,15 +18248,6 @@
     <TaxCatchAll xmlns="230e9df3-be65-4c73-a93b-d1236ebd677e" xsi:nil="true"/>
   </documentManagement>
 </p:properties>
-</file>
-
-<file path=customXml/item2.xml><?xml version="1.0" encoding="utf-8"?>
-<?mso-contentType ?>
-<FormTemplates xmlns="http://schemas.microsoft.com/sharepoint/v3/contenttype/forms">
-  <Display>DocumentLibraryForm</Display>
-  <Edit>DocumentLibraryForm</Edit>
-  <New>DocumentLibraryForm</New>
-</FormTemplates>
 </file>
 
 <file path=customXml/item3.xml><?xml version="1.0" encoding="utf-8"?>
@@ -18592,6 +18557,14 @@
 </file>
 
 <file path=customXml/itemProps1.xml><?xml version="1.0" encoding="utf-8"?>
+<ds:datastoreItem xmlns:ds="http://schemas.openxmlformats.org/officeDocument/2006/customXml" ds:itemID="{3C8E00D1-8EA3-4E42-801D-0253E1EAFC21}">
+  <ds:schemaRefs>
+    <ds:schemaRef ds:uri="http://schemas.microsoft.com/sharepoint/v3/contenttype/forms"/>
+  </ds:schemaRefs>
+</ds:datastoreItem>
+</file>
+
+<file path=customXml/itemProps2.xml><?xml version="1.0" encoding="utf-8"?>
 <ds:datastoreItem xmlns:ds="http://schemas.openxmlformats.org/officeDocument/2006/customXml" ds:itemID="{99919F73-B6C2-4A43-95E2-833EC48925FE}">
   <ds:schemaRefs>
     <ds:schemaRef ds:uri="http://schemas.microsoft.com/office/2006/metadata/properties"/>
@@ -18599,14 +18572,6 @@
     <ds:schemaRef ds:uri="71af3243-3dd4-4a8d-8c0d-dd76da1f02a5"/>
     <ds:schemaRef ds:uri="http://schemas.microsoft.com/sharepoint/v3"/>
     <ds:schemaRef ds:uri="230e9df3-be65-4c73-a93b-d1236ebd677e"/>
-  </ds:schemaRefs>
-</ds:datastoreItem>
-</file>
-
-<file path=customXml/itemProps2.xml><?xml version="1.0" encoding="utf-8"?>
-<ds:datastoreItem xmlns:ds="http://schemas.openxmlformats.org/officeDocument/2006/customXml" ds:itemID="{3C8E00D1-8EA3-4E42-801D-0253E1EAFC21}">
-  <ds:schemaRefs>
-    <ds:schemaRef ds:uri="http://schemas.microsoft.com/sharepoint/v3/contenttype/forms"/>
   </ds:schemaRefs>
 </ds:datastoreItem>
 </file>

</xml_diff>